<commit_message>
Rework the report deck for presenting to an audience
발표 중에 슬라이드만 봐도 따라올 수 있도록 자료를 다시 구성했다.

개념도(00_concept.png)를 새로 그렸다. 카메라가 제자리인데 어떻게 스테레오가
성립하는지가 이 과제의 핵심인데 지금까지 수식으로만 있었다. 세 칸으로 나눠
데이터가 주는 것, 타겟 기준으로 본 같은 상황, 삼각측량을 그림으로 보인다.

모든 그림의 라벨을 한글로 바꾸고 글꼴을 키웠다. matplotlib 에도 Pretendard 가
있어 발표자료와 글꼴을 맞췄다. 그림 캔버스 비율을 슬라이드 카드에 맞춰 여백을
없앴고, 포인트 클라우드 그림은 작게 들어가므로 글자를 따로 키웠다.

슬라이드 제목을 결론 문장으로 바꿨다. 예를 들어 2장은 "정답 깊이 폭 0.90 m 를
0.92 m 로 복원" 이다. 카드 본문은 등폭 표를 줄이고 문장으로 풀었다.

슬라이드마다 발표자 노트를 넣었다. 어느 그림의 어디를 보라고 짚어주는 순서로
쓰였고, 수치는 metrics.json 에서 읽으므로 결과와 어긋나지 않는다.

Co-Authored-By: Claude Opus 5 (1M context) <noreply@anthropic.com>
</commit_message>
<xml_diff>
--- a/report/2차업무_정승원.pptx
+++ b/report/2차업무_정승원.pptx
@@ -6,8 +6,8 @@
   </p:sldMasterIdLst>
   <p:sldIdLst>
     <p:sldId id="256" r:id="rId7"/>
-    <p:sldId id="257" r:id="rId8"/>
-    <p:sldId id="258" r:id="rId9"/>
+    <p:sldId id="257" r:id="rId9"/>
+    <p:sldId id="258" r:id="rId10"/>
   </p:sldIdLst>
   <p:sldSz cx="12191695" cy="6858000" type="screen4x3"/>
   <p:notesSz cx="6858000" cy="9144000"/>
@@ -107,6 +107,744 @@
     </a:lvl9pPr>
   </p:defaultTextStyle>
 </p:presentation>
+</file>
+
+<file path=ppt/notesMasters/notesMaster1.xml><?xml version="1.0" encoding="utf-8"?>
+<p:notesMaster xmlns:a="http://schemas.openxmlformats.org/drawingml/2006/main" xmlns:p="http://schemas.openxmlformats.org/presentationml/2006/main" xmlns:r="http://schemas.openxmlformats.org/officeDocument/2006/relationships">
+  <p:cSld>
+    <p:bg>
+      <p:bgRef idx="1001">
+        <a:schemeClr val="bg1"/>
+      </p:bgRef>
+    </p:bg>
+    <p:spTree>
+      <p:nvGrpSpPr>
+        <p:cNvPr id="1" name=""/>
+        <p:cNvGrpSpPr/>
+        <p:nvPr/>
+      </p:nvGrpSpPr>
+      <p:grpSpPr>
+        <a:xfrm>
+          <a:off x="0" y="0"/>
+          <a:ext cx="0" cy="0"/>
+          <a:chOff x="0" y="0"/>
+          <a:chExt cx="0" cy="0"/>
+        </a:xfrm>
+      </p:grpSpPr>
+      <p:sp>
+        <p:nvSpPr>
+          <p:cNvPr id="2" name="Header Placeholder 1"/>
+          <p:cNvSpPr>
+            <a:spLocks noGrp="1"/>
+          </p:cNvSpPr>
+          <p:nvPr>
+            <p:ph type="hdr" sz="quarter"/>
+          </p:nvPr>
+        </p:nvSpPr>
+        <p:spPr>
+          <a:xfrm>
+            <a:off x="0" y="0"/>
+            <a:ext cx="2971800" cy="457200"/>
+          </a:xfrm>
+          <a:prstGeom prst="rect">
+            <a:avLst/>
+          </a:prstGeom>
+        </p:spPr>
+        <p:txBody>
+          <a:bodyPr vert="horz" lIns="91440" tIns="45720" rIns="91440" bIns="45720" rtlCol="0"/>
+          <a:lstStyle>
+            <a:lvl1pPr algn="l">
+              <a:defRPr sz="1200"/>
+            </a:lvl1pPr>
+          </a:lstStyle>
+          <a:p>
+            <a:endParaRPr lang="en-US"/>
+          </a:p>
+        </p:txBody>
+      </p:sp>
+      <p:sp>
+        <p:nvSpPr>
+          <p:cNvPr id="3" name="Date Placeholder 2"/>
+          <p:cNvSpPr>
+            <a:spLocks noGrp="1"/>
+          </p:cNvSpPr>
+          <p:nvPr>
+            <p:ph type="dt" idx="1"/>
+          </p:nvPr>
+        </p:nvSpPr>
+        <p:spPr>
+          <a:xfrm>
+            <a:off x="3884613" y="0"/>
+            <a:ext cx="2971800" cy="457200"/>
+          </a:xfrm>
+          <a:prstGeom prst="rect">
+            <a:avLst/>
+          </a:prstGeom>
+        </p:spPr>
+        <p:txBody>
+          <a:bodyPr vert="horz" lIns="91440" tIns="45720" rIns="91440" bIns="45720" rtlCol="0"/>
+          <a:lstStyle>
+            <a:lvl1pPr algn="r">
+              <a:defRPr sz="1200"/>
+            </a:lvl1pPr>
+          </a:lstStyle>
+          <a:p>
+            <a:fld id="{0F89C1C7-3DCD-1040-A9CF-14679D8B5DDD}" type="datetimeFigureOut">
+              <a:rPr lang="en-US" smtClean="0"/>
+              <a:t>10/17/16</a:t>
+            </a:fld>
+            <a:endParaRPr lang="en-US"/>
+          </a:p>
+        </p:txBody>
+      </p:sp>
+      <p:sp>
+        <p:nvSpPr>
+          <p:cNvPr id="4" name="Slide Image Placeholder 3"/>
+          <p:cNvSpPr>
+            <a:spLocks noGrp="1" noRot="1" noChangeAspect="1"/>
+          </p:cNvSpPr>
+          <p:nvPr>
+            <p:ph type="sldImg" idx="2"/>
+          </p:nvPr>
+        </p:nvSpPr>
+        <p:spPr>
+          <a:xfrm>
+            <a:off x="1143000" y="685800"/>
+            <a:ext cx="4572000" cy="3429000"/>
+          </a:xfrm>
+          <a:prstGeom prst="rect">
+            <a:avLst/>
+          </a:prstGeom>
+          <a:noFill/>
+          <a:ln w="12700">
+            <a:solidFill>
+              <a:prstClr val="black"/>
+            </a:solidFill>
+          </a:ln>
+        </p:spPr>
+        <p:txBody>
+          <a:bodyPr vert="horz" lIns="91440" tIns="45720" rIns="91440" bIns="45720" rtlCol="0" anchor="ctr"/>
+          <a:lstStyle/>
+          <a:p>
+            <a:endParaRPr lang="en-US"/>
+          </a:p>
+        </p:txBody>
+      </p:sp>
+      <p:sp>
+        <p:nvSpPr>
+          <p:cNvPr id="5" name="Notes Placeholder 4"/>
+          <p:cNvSpPr>
+            <a:spLocks noGrp="1"/>
+          </p:cNvSpPr>
+          <p:nvPr>
+            <p:ph type="body" sz="quarter" idx="3"/>
+          </p:nvPr>
+        </p:nvSpPr>
+        <p:spPr>
+          <a:xfrm>
+            <a:off x="685800" y="4343400"/>
+            <a:ext cx="5486400" cy="4114800"/>
+          </a:xfrm>
+          <a:prstGeom prst="rect">
+            <a:avLst/>
+          </a:prstGeom>
+        </p:spPr>
+        <p:txBody>
+          <a:bodyPr vert="horz" lIns="91440" tIns="45720" rIns="91440" bIns="45720" rtlCol="0"/>
+          <a:lstStyle/>
+          <a:p>
+            <a:pPr lvl="0"/>
+            <a:r>
+              <a:rPr lang="en-US" smtClean="0"/>
+              <a:t>Click to edit Master text styles</a:t>
+            </a:r>
+          </a:p>
+          <a:p>
+            <a:pPr lvl="1"/>
+            <a:r>
+              <a:rPr lang="en-US" smtClean="0"/>
+              <a:t>Second level</a:t>
+            </a:r>
+          </a:p>
+          <a:p>
+            <a:pPr lvl="2"/>
+            <a:r>
+              <a:rPr lang="en-US" smtClean="0"/>
+              <a:t>Third level</a:t>
+            </a:r>
+          </a:p>
+          <a:p>
+            <a:pPr lvl="3"/>
+            <a:r>
+              <a:rPr lang="en-US" smtClean="0"/>
+              <a:t>Fourth level</a:t>
+            </a:r>
+          </a:p>
+          <a:p>
+            <a:pPr lvl="4"/>
+            <a:r>
+              <a:rPr lang="en-US" smtClean="0"/>
+              <a:t>Fifth level</a:t>
+            </a:r>
+            <a:endParaRPr lang="en-US"/>
+          </a:p>
+        </p:txBody>
+      </p:sp>
+      <p:sp>
+        <p:nvSpPr>
+          <p:cNvPr id="6" name="Footer Placeholder 5"/>
+          <p:cNvSpPr>
+            <a:spLocks noGrp="1"/>
+          </p:cNvSpPr>
+          <p:nvPr>
+            <p:ph type="ftr" sz="quarter" idx="4"/>
+          </p:nvPr>
+        </p:nvSpPr>
+        <p:spPr>
+          <a:xfrm>
+            <a:off x="0" y="8685213"/>
+            <a:ext cx="2971800" cy="457200"/>
+          </a:xfrm>
+          <a:prstGeom prst="rect">
+            <a:avLst/>
+          </a:prstGeom>
+        </p:spPr>
+        <p:txBody>
+          <a:bodyPr vert="horz" lIns="91440" tIns="45720" rIns="91440" bIns="45720" rtlCol="0" anchor="b"/>
+          <a:lstStyle>
+            <a:lvl1pPr algn="l">
+              <a:defRPr sz="1200"/>
+            </a:lvl1pPr>
+          </a:lstStyle>
+          <a:p>
+            <a:endParaRPr lang="en-US"/>
+          </a:p>
+        </p:txBody>
+      </p:sp>
+      <p:sp>
+        <p:nvSpPr>
+          <p:cNvPr id="7" name="Slide Number Placeholder 6"/>
+          <p:cNvSpPr>
+            <a:spLocks noGrp="1"/>
+          </p:cNvSpPr>
+          <p:nvPr>
+            <p:ph type="sldNum" sz="quarter" idx="5"/>
+          </p:nvPr>
+        </p:nvSpPr>
+        <p:spPr>
+          <a:xfrm>
+            <a:off x="3884613" y="8685213"/>
+            <a:ext cx="2971800" cy="457200"/>
+          </a:xfrm>
+          <a:prstGeom prst="rect">
+            <a:avLst/>
+          </a:prstGeom>
+        </p:spPr>
+        <p:txBody>
+          <a:bodyPr vert="horz" lIns="91440" tIns="45720" rIns="91440" bIns="45720" rtlCol="0" anchor="b"/>
+          <a:lstStyle>
+            <a:lvl1pPr algn="r">
+              <a:defRPr sz="1200"/>
+            </a:lvl1pPr>
+          </a:lstStyle>
+          <a:p>
+            <a:fld id="{BB5E49A5-4136-284D-997B-48E1D791AD67}" type="slidenum">
+              <a:rPr lang="en-US" smtClean="0"/>
+              <a:t>‹#›</a:t>
+            </a:fld>
+            <a:endParaRPr lang="en-US"/>
+          </a:p>
+        </p:txBody>
+      </p:sp>
+    </p:spTree>
+    <p:extLst>
+      <p:ext uri="{BB962C8B-B14F-4D97-AF65-F5344CB8AC3E}">
+        <p14:creationId xmlns:p14="http://schemas.microsoft.com/office/powerpoint/2010/main" val="2623252185"/>
+      </p:ext>
+    </p:extLst>
+  </p:cSld>
+  <p:clrMap bg1="lt1" tx1="dk1" bg2="lt2" tx2="dk2" accent1="accent1" accent2="accent2" accent3="accent3" accent4="accent4" accent5="accent5" accent6="accent6" hlink="hlink" folHlink="folHlink"/>
+  <p:notesStyle>
+    <a:lvl1pPr marL="0" algn="l" defTabSz="457200" rtl="0" eaLnBrk="1" latinLnBrk="0" hangingPunct="1">
+      <a:defRPr sz="1200" kern="1200">
+        <a:solidFill>
+          <a:schemeClr val="tx1"/>
+        </a:solidFill>
+        <a:latin typeface="+mn-lt"/>
+        <a:ea typeface="+mn-ea"/>
+        <a:cs typeface="+mn-cs"/>
+      </a:defRPr>
+    </a:lvl1pPr>
+    <a:lvl2pPr marL="457200" algn="l" defTabSz="457200" rtl="0" eaLnBrk="1" latinLnBrk="0" hangingPunct="1">
+      <a:defRPr sz="1200" kern="1200">
+        <a:solidFill>
+          <a:schemeClr val="tx1"/>
+        </a:solidFill>
+        <a:latin typeface="+mn-lt"/>
+        <a:ea typeface="+mn-ea"/>
+        <a:cs typeface="+mn-cs"/>
+      </a:defRPr>
+    </a:lvl2pPr>
+    <a:lvl3pPr marL="914400" algn="l" defTabSz="457200" rtl="0" eaLnBrk="1" latinLnBrk="0" hangingPunct="1">
+      <a:defRPr sz="1200" kern="1200">
+        <a:solidFill>
+          <a:schemeClr val="tx1"/>
+        </a:solidFill>
+        <a:latin typeface="+mn-lt"/>
+        <a:ea typeface="+mn-ea"/>
+        <a:cs typeface="+mn-cs"/>
+      </a:defRPr>
+    </a:lvl3pPr>
+    <a:lvl4pPr marL="1371600" algn="l" defTabSz="457200" rtl="0" eaLnBrk="1" latinLnBrk="0" hangingPunct="1">
+      <a:defRPr sz="1200" kern="1200">
+        <a:solidFill>
+          <a:schemeClr val="tx1"/>
+        </a:solidFill>
+        <a:latin typeface="+mn-lt"/>
+        <a:ea typeface="+mn-ea"/>
+        <a:cs typeface="+mn-cs"/>
+      </a:defRPr>
+    </a:lvl4pPr>
+    <a:lvl5pPr marL="1828800" algn="l" defTabSz="457200" rtl="0" eaLnBrk="1" latinLnBrk="0" hangingPunct="1">
+      <a:defRPr sz="1200" kern="1200">
+        <a:solidFill>
+          <a:schemeClr val="tx1"/>
+        </a:solidFill>
+        <a:latin typeface="+mn-lt"/>
+        <a:ea typeface="+mn-ea"/>
+        <a:cs typeface="+mn-cs"/>
+      </a:defRPr>
+    </a:lvl5pPr>
+    <a:lvl6pPr marL="2286000" algn="l" defTabSz="457200" rtl="0" eaLnBrk="1" latinLnBrk="0" hangingPunct="1">
+      <a:defRPr sz="1200" kern="1200">
+        <a:solidFill>
+          <a:schemeClr val="tx1"/>
+        </a:solidFill>
+        <a:latin typeface="+mn-lt"/>
+        <a:ea typeface="+mn-ea"/>
+        <a:cs typeface="+mn-cs"/>
+      </a:defRPr>
+    </a:lvl6pPr>
+    <a:lvl7pPr marL="2743200" algn="l" defTabSz="457200" rtl="0" eaLnBrk="1" latinLnBrk="0" hangingPunct="1">
+      <a:defRPr sz="1200" kern="1200">
+        <a:solidFill>
+          <a:schemeClr val="tx1"/>
+        </a:solidFill>
+        <a:latin typeface="+mn-lt"/>
+        <a:ea typeface="+mn-ea"/>
+        <a:cs typeface="+mn-cs"/>
+      </a:defRPr>
+    </a:lvl7pPr>
+    <a:lvl8pPr marL="3200400" algn="l" defTabSz="457200" rtl="0" eaLnBrk="1" latinLnBrk="0" hangingPunct="1">
+      <a:defRPr sz="1200" kern="1200">
+        <a:solidFill>
+          <a:schemeClr val="tx1"/>
+        </a:solidFill>
+        <a:latin typeface="+mn-lt"/>
+        <a:ea typeface="+mn-ea"/>
+        <a:cs typeface="+mn-cs"/>
+      </a:defRPr>
+    </a:lvl8pPr>
+    <a:lvl9pPr marL="3657600" algn="l" defTabSz="457200" rtl="0" eaLnBrk="1" latinLnBrk="0" hangingPunct="1">
+      <a:defRPr sz="1200" kern="1200">
+        <a:solidFill>
+          <a:schemeClr val="tx1"/>
+        </a:solidFill>
+        <a:latin typeface="+mn-lt"/>
+        <a:ea typeface="+mn-ea"/>
+        <a:cs typeface="+mn-cs"/>
+      </a:defRPr>
+    </a:lvl9pPr>
+  </p:notesStyle>
+</p:notesMaster>
+</file>
+
+<file path=ppt/notesSlides/notesSlide1.xml><?xml version="1.0" encoding="utf-8"?>
+<p:notes xmlns:a="http://schemas.openxmlformats.org/drawingml/2006/main" xmlns:p="http://schemas.openxmlformats.org/presentationml/2006/main" xmlns:r="http://schemas.openxmlformats.org/officeDocument/2006/relationships">
+  <p:cSld>
+    <p:spTree>
+      <p:nvGrpSpPr>
+        <p:cNvPr id="1" name=""/>
+        <p:cNvGrpSpPr/>
+        <p:nvPr/>
+      </p:nvGrpSpPr>
+      <p:grpSpPr>
+        <a:xfrm>
+          <a:off x="0" y="0"/>
+          <a:ext cx="0" cy="0"/>
+          <a:chOff x="0" y="0"/>
+          <a:chExt cx="0" cy="0"/>
+        </a:xfrm>
+      </p:grpSpPr>
+      <p:sp>
+        <p:nvSpPr>
+          <p:cNvPr id="2" name="Slide Image Placeholder 1"/>
+          <p:cNvSpPr>
+            <a:spLocks noGrp="1"/>
+          </p:cNvSpPr>
+          <p:nvPr>
+            <p:ph type="sldImg" idx="2"/>
+          </p:nvPr>
+        </p:nvSpPr>
+        <p:spPr/>
+      </p:sp>
+      <p:sp>
+        <p:nvSpPr>
+          <p:cNvPr id="3" name="Notes Placeholder 2"/>
+          <p:cNvSpPr>
+            <a:spLocks noGrp="1"/>
+          </p:cNvSpPr>
+          <p:nvPr>
+            <p:ph type="body" idx="3" sz="quarter"/>
+          </p:nvPr>
+        </p:nvSpPr>
+        <p:spPr/>
+        <p:txBody>
+          <a:bodyPr/>
+          <a:lstStyle/>
+          <a:p>
+            <a:r>
+              <a:t>이번 과제는 위성 근접 영상에서 깊이 맵을 만들고 3D 포인트 클라우드로 바꾸는 것입니다.</a:t>
+            </a:r>
+          </a:p>
+          <a:p/>
+          <a:p>
+            <a:r>
+              <a:t>영상 한 장으로는 깊이를 알 수 없습니다. 한 시선 위에 있는 점들이 전부 같은 화소에</a:t>
+            </a:r>
+          </a:p>
+          <a:p>
+            <a:r>
+              <a:t>맺히기 때문입니다. 그래서 시점이 두 개 필요합니다.</a:t>
+            </a:r>
+          </a:p>
+          <a:p/>
+          <a:p>
+            <a:r>
+              <a:t>그런데 쓴 데이터셋은 카메라가 제자리에 고정돼 있습니다. 왼쪽 그림처럼 병진이 항상</a:t>
+            </a:r>
+          </a:p>
+          <a:p>
+            <a:r>
+              <a:t>(0, 0, Z)라서, 카메라 좌표계만 보면 베이스라인이 없습니다.</a:t>
+            </a:r>
+          </a:p>
+          <a:p/>
+          <a:p>
+            <a:r>
+              <a:t>대신 타겟이 매 프레임 무작위로 회전합니다. 가운데 그림처럼 타겟을 기준으로 보면</a:t>
+            </a:r>
+          </a:p>
+          <a:p>
+            <a:r>
+              <a:t>카메라가 궤도를 돈 것과 같습니다. 두 뷰의 상대 자세를 계산하면 회전 4.50도짜리</a:t>
+            </a:r>
+          </a:p>
+          <a:p>
+            <a:r>
+              <a:t>쌍에서 베이스라인 0.366 미터가 나옵니다.</a:t>
+            </a:r>
+          </a:p>
+          <a:p/>
+          <a:p>
+            <a:r>
+              <a:t>이걸 평행 정렬하면 오른쪽처럼 표준 삼각측량 공식 Z = f 곱하기 B 나누기 d 를</a:t>
+            </a:r>
+          </a:p>
+          <a:p>
+            <a:r>
+              <a:t>그대로 쓸 수 있습니다. 시차 1픽셀이 깊이 6.8 센티미터에 해당합니다.</a:t>
+            </a:r>
+          </a:p>
+        </p:txBody>
+      </p:sp>
+      <p:sp>
+        <p:nvSpPr>
+          <p:cNvPr id="4" name="Slide Number Placeholder 3"/>
+          <p:cNvSpPr>
+            <a:spLocks noGrp="1"/>
+          </p:cNvSpPr>
+          <p:nvPr>
+            <p:ph type="sldNum" idx="5" sz="quarter"/>
+          </p:nvPr>
+        </p:nvSpPr>
+        <p:spPr/>
+      </p:sp>
+    </p:spTree>
+  </p:cSld>
+  <p:clrMapOvr>
+    <a:masterClrMapping/>
+  </p:clrMapOvr>
+</p:notes>
+</file>
+
+<file path=ppt/notesSlides/notesSlide2.xml><?xml version="1.0" encoding="utf-8"?>
+<p:notes xmlns:a="http://schemas.openxmlformats.org/drawingml/2006/main" xmlns:p="http://schemas.openxmlformats.org/presentationml/2006/main" xmlns:r="http://schemas.openxmlformats.org/officeDocument/2006/relationships">
+  <p:cSld>
+    <p:spTree>
+      <p:nvGrpSpPr>
+        <p:cNvPr id="1" name=""/>
+        <p:cNvGrpSpPr/>
+        <p:nvPr/>
+      </p:nvGrpSpPr>
+      <p:grpSpPr>
+        <a:xfrm>
+          <a:off x="0" y="0"/>
+          <a:ext cx="0" cy="0"/>
+          <a:chOff x="0" y="0"/>
+          <a:chExt cx="0" cy="0"/>
+        </a:xfrm>
+      </p:grpSpPr>
+      <p:sp>
+        <p:nvSpPr>
+          <p:cNvPr id="2" name="Slide Image Placeholder 1"/>
+          <p:cNvSpPr>
+            <a:spLocks noGrp="1"/>
+          </p:cNvSpPr>
+          <p:nvPr>
+            <p:ph type="sldImg" idx="2"/>
+          </p:nvPr>
+        </p:nvSpPr>
+        <p:spPr/>
+      </p:sp>
+      <p:sp>
+        <p:nvSpPr>
+          <p:cNvPr id="3" name="Notes Placeholder 2"/>
+          <p:cNvSpPr>
+            <a:spLocks noGrp="1"/>
+          </p:cNvSpPr>
+          <p:nvPr>
+            <p:ph type="body" idx="3" sz="quarter"/>
+          </p:nvPr>
+        </p:nvSpPr>
+        <p:spPr/>
+        <p:txBody>
+          <a:bodyPr/>
+          <a:lstStyle/>
+          <a:p>
+            <a:r>
+              <a:t>실제 데이터에 적용하기 전에, 정답을 아는 조건에서 파이프라인이 맞는지 먼저 확인했습니다.</a:t>
+            </a:r>
+          </a:p>
+          <a:p/>
+          <a:p>
+            <a:r>
+              <a:t>구와 직육면체로 위성을 세우면 광선과 도형의 교차를 손으로 풀 수 있습니다. 그래서</a:t>
+            </a:r>
+          </a:p>
+          <a:p>
+            <a:r>
+              <a:t>정답 깊이에 렌더링 오차가 전혀 없고, 남는 오차는 전부 정합 알고리즘에서 온 것입니다.</a:t>
+            </a:r>
+          </a:p>
+          <a:p/>
+          <a:p>
+            <a:r>
+              <a:t>오른쪽 세 장을 비교해 주십시오. 네 번째가 정답 깊이인데, 태양전지판 왼쪽 끝과</a:t>
+            </a:r>
+          </a:p>
+          <a:p>
+            <a:r>
+              <a:t>오른쪽 끝이 0.90 미터 차이 납니다. 다섯 번째 스테레오 복원이 그 차이를</a:t>
+            </a:r>
+          </a:p>
+          <a:p>
+            <a:r>
+              <a:t>0.92 미터로 되살립니다. 마지막 과제 예시 코드는 0.017 미터,</a:t>
+            </a:r>
+          </a:p>
+          <a:p>
+            <a:r>
+              <a:t>사실상 평면 하나입니다.</a:t>
+            </a:r>
+          </a:p>
+          <a:p/>
+          <a:p>
+            <a:r>
+              <a:t>오차 중앙값은 1.0 센티미터 대 7.2 센티미터,</a:t>
+            </a:r>
+          </a:p>
+          <a:p>
+            <a:r>
+              <a:t>5센티미터 안에 든 화소는 96.1 퍼센트 대 33.5 퍼센트입니다.</a:t>
+            </a:r>
+          </a:p>
+          <a:p>
+            <a:r>
+              <a:t>예시 코드에는 정답에 맞춘 최적 정렬까지 해 준 결과입니다.</a:t>
+            </a:r>
+          </a:p>
+          <a:p/>
+          <a:p>
+            <a:r>
+              <a:t>Unit Test 는 65개입니다. 출력 크기와 자료형만 보면 수식이 틀려도 통과하기 때문에,</a:t>
+            </a:r>
+          </a:p>
+          <a:p>
+            <a:r>
+              <a:t>손으로 풀 수 있는 조건을 만들어 수치까지 대조했습니다.</a:t>
+            </a:r>
+          </a:p>
+        </p:txBody>
+      </p:sp>
+      <p:sp>
+        <p:nvSpPr>
+          <p:cNvPr id="4" name="Slide Number Placeholder 3"/>
+          <p:cNvSpPr>
+            <a:spLocks noGrp="1"/>
+          </p:cNvSpPr>
+          <p:nvPr>
+            <p:ph type="sldNum" idx="5" sz="quarter"/>
+          </p:nvPr>
+        </p:nvSpPr>
+        <p:spPr/>
+      </p:sp>
+    </p:spTree>
+  </p:cSld>
+  <p:clrMapOvr>
+    <a:masterClrMapping/>
+  </p:clrMapOvr>
+</p:notes>
+</file>
+
+<file path=ppt/notesSlides/notesSlide3.xml><?xml version="1.0" encoding="utf-8"?>
+<p:notes xmlns:a="http://schemas.openxmlformats.org/drawingml/2006/main" xmlns:p="http://schemas.openxmlformats.org/presentationml/2006/main" xmlns:r="http://schemas.openxmlformats.org/officeDocument/2006/relationships">
+  <p:cSld>
+    <p:spTree>
+      <p:nvGrpSpPr>
+        <p:cNvPr id="1" name=""/>
+        <p:cNvGrpSpPr/>
+        <p:nvPr/>
+      </p:nvGrpSpPr>
+      <p:grpSpPr>
+        <a:xfrm>
+          <a:off x="0" y="0"/>
+          <a:ext cx="0" cy="0"/>
+          <a:chOff x="0" y="0"/>
+          <a:chExt cx="0" cy="0"/>
+        </a:xfrm>
+      </p:grpSpPr>
+      <p:sp>
+        <p:nvSpPr>
+          <p:cNvPr id="2" name="Slide Image Placeholder 1"/>
+          <p:cNvSpPr>
+            <a:spLocks noGrp="1"/>
+          </p:cNvSpPr>
+          <p:nvPr>
+            <p:ph type="sldImg" idx="2"/>
+          </p:nvPr>
+        </p:nvSpPr>
+        <p:spPr/>
+      </p:sp>
+      <p:sp>
+        <p:nvSpPr>
+          <p:cNvPr id="3" name="Notes Placeholder 2"/>
+          <p:cNvSpPr>
+            <a:spLocks noGrp="1"/>
+          </p:cNvSpPr>
+          <p:nvPr>
+            <p:ph type="body" idx="3" sz="quarter"/>
+          </p:nvPr>
+        </p:nvSpPr>
+        <p:spPr/>
+        <p:txBody>
+          <a:bodyPr/>
+          <a:lstStyle/>
+          <a:p>
+            <a:r>
+              <a:t>실제 SPE3R 위성 영상 결과입니다.</a:t>
+            </a:r>
+          </a:p>
+          <a:p/>
+          <a:p>
+            <a:r>
+              <a:t>왼쪽 두 장이 정렬된 스테레오 쌍입니다. 배경에 지구가 보이고, 타겟이 4.50도</a:t>
+            </a:r>
+          </a:p>
+          <a:p>
+            <a:r>
+              <a:t>돌아간 두 시점입니다. 세 번째가 찾아낸 시차이고, 네 번째가 동봉된 메시로 만든 기준 깊이입니다.</a:t>
+            </a:r>
+          </a:p>
+          <a:p/>
+          <a:p>
+            <a:r>
+              <a:t>네 번째와 다섯 번째를 비교해 주십시오. 기준 깊이는 위쪽 태양전지판이 노랗고 아래</a:t>
+            </a:r>
+          </a:p>
+          <a:p>
+            <a:r>
+              <a:t>본체로 갈수록 파래지는 그라데이션인데, 스테레오 복원이 그 구조를 그대로 잡아냅니다.</a:t>
+            </a:r>
+          </a:p>
+          <a:p>
+            <a:r>
+              <a:t>반면 맨 오른쪽 과제 예시 코드는 거의 균일한 초록입니다. 깊이 정보가 없다는 뜻입니다.</a:t>
+            </a:r>
+          </a:p>
+          <a:p/>
+          <a:p>
+            <a:r>
+              <a:t>수치로는 오차 중앙값 0.9 센티미터, 5센티미터 이내가 90.3 퍼센트입니다.</a:t>
+            </a:r>
+          </a:p>
+          <a:p>
+            <a:r>
+              <a:t>예시 코드는 4.9 센티미터, 50.8 퍼센트입니다.</a:t>
+            </a:r>
+          </a:p>
+          <a:p/>
+          <a:p>
+            <a:r>
+              <a:t>이 깊이 맵을 역투영하면 오른쪽 아래 포인트 클라우드가 나옵니다. 4,998점이고</a:t>
+            </a:r>
+          </a:p>
+          <a:p>
+            <a:r>
+              <a:t>정답 메시 대비 Chamfer 거리는 0.0120 입니다.</a:t>
+            </a:r>
+          </a:p>
+          <a:p/>
+          <a:p>
+            <a:r>
+              <a:t>한계도 말씀드리겠습니다. 조건을 만족하는 쌍이 후보 20개 중 3개뿐이고,</a:t>
+            </a:r>
+          </a:p>
+          <a:p>
+            <a:r>
+              <a:t>유효 화소는 59 퍼센트입니다. 단일 시점이라 타겟 뒷면은 원리적으로</a:t>
+            </a:r>
+          </a:p>
+          <a:p>
+            <a:r>
+              <a:t>복원되지 않고, 자세는 데이터셋이 준 정답을 그대로 썼습니다. 실제 상대항법에서는</a:t>
+            </a:r>
+          </a:p>
+          <a:p>
+            <a:r>
+              <a:t>자세도 추정해야 하고 그 오차가 삼각측량에 미치는 영향은 이번에 측정하지 않았습니다.</a:t>
+            </a:r>
+          </a:p>
+        </p:txBody>
+      </p:sp>
+      <p:sp>
+        <p:nvSpPr>
+          <p:cNvPr id="4" name="Slide Number Placeholder 3"/>
+          <p:cNvSpPr>
+            <a:spLocks noGrp="1"/>
+          </p:cNvSpPr>
+          <p:nvPr>
+            <p:ph type="sldNum" idx="5" sz="quarter"/>
+          </p:nvPr>
+        </p:nvSpPr>
+        <p:spPr/>
+      </p:sp>
+    </p:spTree>
+  </p:cSld>
+  <p:clrMapOvr>
+    <a:masterClrMapping/>
+  </p:clrMapOvr>
+</p:notes>
 </file>
 
 <file path=ppt/slideLayouts/slideLayout1.xml><?xml version="1.0" encoding="utf-8"?>
@@ -3170,7 +3908,7 @@
                 <a:ea typeface="Cascadia Mono"/>
                 <a:cs typeface="Cascadia Mono"/>
               </a:rPr>
-              <a:t>01 / STEREO TRIANGULATION</a:t>
+              <a:t>01 / 방법</a:t>
             </a:r>
           </a:p>
         </p:txBody>
@@ -3211,7 +3949,7 @@
                 <a:ea typeface="Pretendard SemiBold"/>
                 <a:cs typeface="Pretendard SemiBold"/>
               </a:rPr>
-              <a:t>두 장의 영상에서 깊이 맵과 3D 포인트 클라우드</a:t>
+              <a:t>카메라가 고정이어도 타겟이 돌면 스테레오가 된다</a:t>
             </a:r>
           </a:p>
         </p:txBody>
@@ -3252,7 +3990,7 @@
                 <a:ea typeface="Pretendard"/>
                 <a:cs typeface="Pretendard"/>
               </a:rPr>
-              <a:t>SPE3R aqua · 256×256 · f = 1277.4 px · Stanford SLAB · CC BY-NC-SA 4.0</a:t>
+              <a:t>SPE3R aqua · 위성 근접 영상 1,000장 · 256×256 · Stanford SLAB · CC BY-NC-SA 4.0</a:t>
             </a:r>
           </a:p>
         </p:txBody>
@@ -3348,7 +4086,7 @@
       </p:sp>
       <p:pic>
         <p:nvPicPr>
-          <p:cNvPr id="8" name="Picture 7" descr="03_spe3r_stereo.png"/>
+          <p:cNvPr id="8" name="Picture 7" descr="00_concept.png"/>
           <p:cNvPicPr>
             <a:picLocks noChangeAspect="1"/>
           </p:cNvPicPr>
@@ -3362,8 +4100,8 @@
         </p:blipFill>
         <p:spPr>
           <a:xfrm>
-            <a:off x="795528" y="1878300"/>
-            <a:ext cx="10597896" cy="2241862"/>
+            <a:off x="1346629" y="1764792"/>
+            <a:ext cx="9495692" cy="2468880"/>
           </a:xfrm>
           <a:prstGeom prst="rect">
             <a:avLst/>
@@ -3372,59 +4110,18 @@
       </p:pic>
       <p:sp>
         <p:nvSpPr>
-          <p:cNvPr id="9" name="TextBox 8"/>
-          <p:cNvSpPr txBox="1"/>
-          <p:nvPr/>
-        </p:nvSpPr>
-        <p:spPr>
-          <a:xfrm>
-            <a:off x="658368" y="4434840"/>
-            <a:ext cx="10872216" cy="182880"/>
-          </a:xfrm>
-          <a:prstGeom prst="rect">
-            <a:avLst/>
-          </a:prstGeom>
-          <a:noFill/>
-        </p:spPr>
-        <p:txBody>
-          <a:bodyPr wrap="square" lIns="0" rIns="0" tIns="0" bIns="0">
-            <a:spAutoFit/>
-          </a:bodyPr>
-          <a:lstStyle/>
-          <a:p>
-            <a:pPr algn="l">
-              <a:lnSpc>
-                <a:spcPct val="135000"/>
-              </a:lnSpc>
-            </a:pPr>
-            <a:r>
-              <a:rPr sz="850" b="0">
-                <a:solidFill>
-                  <a:srgbClr val="8F8F8F"/>
-                </a:solidFill>
-                <a:latin typeface="Cascadia Mono"/>
-                <a:ea typeface="Cascadia Mono"/>
-                <a:cs typeface="Cascadia Mono"/>
-              </a:rPr>
-              <a:t>RECTIFIED PAIR · DISPARITY · REFERENCE DEPTH · STEREO DEPTH · EXAMPLE CODE</a:t>
-            </a:r>
-          </a:p>
-        </p:txBody>
-      </p:sp>
-      <p:sp>
-        <p:nvSpPr>
-          <p:cNvPr id="10" name="Rounded Rectangle 9"/>
+          <p:cNvPr id="9" name="Rounded Rectangle 8"/>
           <p:cNvSpPr/>
           <p:nvPr/>
         </p:nvSpPr>
         <p:spPr>
           <a:xfrm>
-            <a:off x="658368" y="4681728"/>
-            <a:ext cx="5358384" cy="1581912"/>
+            <a:off x="658368" y="4590288"/>
+            <a:ext cx="5358384" cy="1673352"/>
           </a:xfrm>
           <a:prstGeom prst="roundRect">
             <a:avLst>
-              <a:gd name="adj" fmla="val 7225"/>
+              <a:gd name="adj" fmla="val 6830"/>
             </a:avLst>
           </a:prstGeom>
           <a:solidFill>
@@ -3461,13 +4158,13 @@
       </p:sp>
       <p:sp>
         <p:nvSpPr>
-          <p:cNvPr id="11" name="TextBox 10"/>
+          <p:cNvPr id="10" name="TextBox 9"/>
           <p:cNvSpPr txBox="1"/>
           <p:nvPr/>
         </p:nvSpPr>
         <p:spPr>
           <a:xfrm>
-            <a:off x="896112" y="4855464"/>
+            <a:off x="896112" y="4764024"/>
             <a:ext cx="4882896" cy="219456"/>
           </a:xfrm>
           <a:prstGeom prst="rect">
@@ -3495,21 +4192,21 @@
                 <a:ea typeface="Pretendard SemiBold"/>
                 <a:cs typeface="Pretendard SemiBold"/>
               </a:rPr>
-              <a:t>두 번째 시점을 어떻게 얻는가</a:t>
-            </a:r>
-          </a:p>
-        </p:txBody>
-      </p:sp>
-      <p:sp>
-        <p:nvSpPr>
-          <p:cNvPr id="12" name="TextBox 11"/>
+              <a:t>왜 시점이 두 개 필요한가</a:t>
+            </a:r>
+          </a:p>
+        </p:txBody>
+      </p:sp>
+      <p:sp>
+        <p:nvSpPr>
+          <p:cNvPr id="11" name="TextBox 10"/>
           <p:cNvSpPr txBox="1"/>
           <p:nvPr/>
         </p:nvSpPr>
         <p:spPr>
           <a:xfrm>
-            <a:off x="896112" y="5102352"/>
-            <a:ext cx="4882896" cy="978407"/>
+            <a:off x="896112" y="5010912"/>
+            <a:ext cx="4882896" cy="1069848"/>
           </a:xfrm>
           <a:prstGeom prst="rect">
             <a:avLst/>
@@ -3528,7 +4225,7 @@
               </a:lnSpc>
             </a:pPr>
             <a:r>
-              <a:rPr sz="950" b="0">
+              <a:rPr sz="1000" b="0">
                 <a:solidFill>
                   <a:srgbClr val="4D4D4D"/>
                 </a:solidFill>
@@ -3536,7 +4233,7 @@
                 <a:ea typeface="Pretendard"/>
                 <a:cs typeface="Pretendard"/>
               </a:rPr>
-              <a:t>포즈 라벨 1,000개를 재보면 병진이 항상 (0, 0, Z)입니다.</a:t>
+              <a:t>영상 한 장은 깊이를 잃습니다. 한 시선 위의 모든 점이</a:t>
             </a:r>
           </a:p>
           <a:p>
@@ -3546,7 +4243,7 @@
               </a:lnSpc>
             </a:pPr>
             <a:r>
-              <a:rPr sz="950" b="0">
+              <a:rPr sz="1000" b="0">
                 <a:solidFill>
                   <a:srgbClr val="4D4D4D"/>
                 </a:solidFill>
@@ -3554,7 +4251,7 @@
                 <a:ea typeface="Pretendard"/>
                 <a:cs typeface="Pretendard"/>
               </a:rPr>
-              <a:t>카메라 좌표계만 보면 베이스라인이 없습니다.</a:t>
+              <a:t>같은 화소에 맺히기 때문입니다.</a:t>
             </a:r>
           </a:p>
           <a:p>
@@ -3564,15 +4261,15 @@
               </a:lnSpc>
             </a:pPr>
             <a:r>
-              <a:rPr sz="950" b="0">
-                <a:solidFill>
-                  <a:srgbClr val="171717"/>
-                </a:solidFill>
-                <a:latin typeface="Pretendard Medium"/>
-                <a:ea typeface="Pretendard Medium"/>
-                <a:cs typeface="Pretendard Medium"/>
+              <a:rPr sz="400" b="0">
+                <a:solidFill>
+                  <a:srgbClr val="4D4D4D"/>
+                </a:solidFill>
+                <a:latin typeface="Pretendard"/>
+                <a:ea typeface="Pretendard"/>
+                <a:cs typeface="Pretendard"/>
               </a:rPr>
-              <a:t>삼각측량에 필요한 것은 카메라와 타겟 사이의 상대 운동입니다.</a:t>
+              <a:t/>
             </a:r>
           </a:p>
           <a:p>
@@ -3582,7 +4279,7 @@
               </a:lnSpc>
             </a:pPr>
             <a:r>
-              <a:rPr sz="950" b="0">
+              <a:rPr sz="1000" b="0">
                 <a:solidFill>
                   <a:srgbClr val="171717"/>
                 </a:solidFill>
@@ -3590,7 +4287,7 @@
                 <a:ea typeface="Pretendard Medium"/>
                 <a:cs typeface="Pretendard Medium"/>
               </a:rPr>
-              <a:t>타겟이 회전하므로 타겟 기준으로는 카메라가 궤도를 돈 것과 같습니다.</a:t>
+              <a:t>SPE3R은 카메라가 제자리에 고정돼 있습니다.</a:t>
             </a:r>
           </a:p>
           <a:p>
@@ -3600,15 +4297,15 @@
               </a:lnSpc>
             </a:pPr>
             <a:r>
-              <a:rPr sz="850" b="0">
-                <a:solidFill>
-                  <a:srgbClr val="4D4D4D"/>
-                </a:solidFill>
-                <a:latin typeface="Cascadia Mono"/>
-                <a:ea typeface="Cascadia Mono"/>
-                <a:cs typeface="Cascadia Mono"/>
+              <a:rPr sz="1000" b="0">
+                <a:solidFill>
+                  <a:srgbClr val="171717"/>
+                </a:solidFill>
+                <a:latin typeface="Pretendard Medium"/>
+                <a:ea typeface="Pretendard Medium"/>
+                <a:cs typeface="Pretendard Medium"/>
               </a:rPr>
-              <a:t>R_ij = R_j · R_iᵀ        t_ij = t_j − R_ij · t_i</a:t>
+              <a:t>대신 타겟이 매 프레임 무작위로 회전합니다.</a:t>
             </a:r>
           </a:p>
           <a:p>
@@ -3618,33 +4315,33 @@
               </a:lnSpc>
             </a:pPr>
             <a:r>
-              <a:rPr sz="950" b="0">
-                <a:solidFill>
-                  <a:srgbClr val="171717"/>
-                </a:solidFill>
-                <a:latin typeface="Pretendard Medium"/>
-                <a:ea typeface="Pretendard Medium"/>
-                <a:cs typeface="Pretendard Medium"/>
+              <a:rPr sz="1000" b="0">
+                <a:solidFill>
+                  <a:srgbClr val="4D4D4D"/>
+                </a:solidFill>
+                <a:latin typeface="Pretendard"/>
+                <a:ea typeface="Pretendard"/>
+                <a:cs typeface="Pretendard"/>
               </a:rPr>
-              <a:t>회전 4.50° 쌍에서 유효 베이스라인 0.366 m 확보</a:t>
-            </a:r>
-          </a:p>
-        </p:txBody>
-      </p:sp>
-      <p:sp>
-        <p:nvSpPr>
-          <p:cNvPr id="13" name="Rounded Rectangle 12"/>
+              <a:t>이 회전이 카메라를 궤도에 올린 것과 같은 효과를 냅니다.</a:t>
+            </a:r>
+          </a:p>
+        </p:txBody>
+      </p:sp>
+      <p:sp>
+        <p:nvSpPr>
+          <p:cNvPr id="12" name="Rounded Rectangle 11"/>
           <p:cNvSpPr/>
           <p:nvPr/>
         </p:nvSpPr>
         <p:spPr>
           <a:xfrm>
-            <a:off x="6364224" y="4681728"/>
-            <a:ext cx="5166360" cy="1581912"/>
+            <a:off x="6364224" y="4590288"/>
+            <a:ext cx="5166360" cy="1673352"/>
           </a:xfrm>
           <a:prstGeom prst="roundRect">
             <a:avLst>
-              <a:gd name="adj" fmla="val 7225"/>
+              <a:gd name="adj" fmla="val 6830"/>
             </a:avLst>
           </a:prstGeom>
           <a:solidFill>
@@ -3681,13 +4378,13 @@
       </p:sp>
       <p:sp>
         <p:nvSpPr>
-          <p:cNvPr id="14" name="TextBox 13"/>
+          <p:cNvPr id="13" name="TextBox 12"/>
           <p:cNvSpPr txBox="1"/>
           <p:nvPr/>
         </p:nvSpPr>
         <p:spPr>
           <a:xfrm>
-            <a:off x="6601968" y="4855464"/>
+            <a:off x="6601968" y="4764024"/>
             <a:ext cx="4690872" cy="219456"/>
           </a:xfrm>
           <a:prstGeom prst="rect">
@@ -3715,21 +4412,21 @@
                 <a:ea typeface="Pretendard SemiBold"/>
                 <a:cs typeface="Pretendard SemiBold"/>
               </a:rPr>
-              <a:t>파이프라인</a:t>
-            </a:r>
-          </a:p>
-        </p:txBody>
-      </p:sp>
-      <p:sp>
-        <p:nvSpPr>
-          <p:cNvPr id="15" name="TextBox 14"/>
+              <a:t>파이프라인 5단계</a:t>
+            </a:r>
+          </a:p>
+        </p:txBody>
+      </p:sp>
+      <p:sp>
+        <p:nvSpPr>
+          <p:cNvPr id="14" name="TextBox 13"/>
           <p:cNvSpPr txBox="1"/>
           <p:nvPr/>
         </p:nvSpPr>
         <p:spPr>
           <a:xfrm>
-            <a:off x="6601968" y="5102352"/>
-            <a:ext cx="4690872" cy="978407"/>
+            <a:off x="6601968" y="5010912"/>
+            <a:ext cx="4690872" cy="1069848"/>
           </a:xfrm>
           <a:prstGeom prst="rect">
             <a:avLst/>
@@ -3748,7 +4445,7 @@
               </a:lnSpc>
             </a:pPr>
             <a:r>
-              <a:rPr sz="950" b="0">
+              <a:rPr sz="1000" b="0">
                 <a:solidFill>
                   <a:srgbClr val="4D4D4D"/>
                 </a:solidFill>
@@ -3756,7 +4453,7 @@
                 <a:ea typeface="Pretendard"/>
                 <a:cs typeface="Pretendard"/>
               </a:rPr>
-              <a:t>① 쌍 선별 — 회전 8° 이내 + 베이스라인의 횡방향 성분이 지배적일 것</a:t>
+              <a:t>① 쌍 선별 — 회전 8° 이내, 옆으로 움직인 쌍만</a:t>
             </a:r>
           </a:p>
           <a:p>
@@ -3766,7 +4463,7 @@
               </a:lnSpc>
             </a:pPr>
             <a:r>
-              <a:rPr sz="950" b="0">
+              <a:rPr sz="1000" b="0">
                 <a:solidFill>
                   <a:srgbClr val="4D4D4D"/>
                 </a:solidFill>
@@ -3774,7 +4471,7 @@
                 <a:ea typeface="Pretendard"/>
                 <a:cs typeface="Pretendard"/>
               </a:rPr>
-              <a:t>② cv2.stereoRectify — 에피폴라선을 가로 행으로 정렬</a:t>
+              <a:t>② 정렬 — cv2.stereoRectify 로 에피폴라선을 가로로</a:t>
             </a:r>
           </a:p>
           <a:p>
@@ -3784,7 +4481,7 @@
               </a:lnSpc>
             </a:pPr>
             <a:r>
-              <a:rPr sz="950" b="0">
+              <a:rPr sz="1000" b="0">
                 <a:solidFill>
                   <a:srgbClr val="4D4D4D"/>
                 </a:solidFill>
@@ -3792,7 +4489,7 @@
                 <a:ea typeface="Pretendard"/>
                 <a:cs typeface="Pretendard"/>
               </a:rPr>
-              <a:t>③ cv2.StereoSGBM — 화소마다 가로 이동량 d 탐색</a:t>
+              <a:t>③ 시차 — cv2.StereoSGBM 으로 가로 이동량 d 탐색</a:t>
             </a:r>
           </a:p>
           <a:p>
@@ -3802,7 +4499,7 @@
               </a:lnSpc>
             </a:pPr>
             <a:r>
-              <a:rPr sz="950" b="0">
+              <a:rPr sz="1000" b="0">
                 <a:solidFill>
                   <a:srgbClr val="171717"/>
                 </a:solidFill>
@@ -3810,7 +4507,7 @@
                 <a:ea typeface="Pretendard Medium"/>
                 <a:cs typeface="Pretendard Medium"/>
               </a:rPr>
-              <a:t>④ Z = f · B / d          ← 깊이 맵 (미터 단위)</a:t>
+              <a:t>④ 깊이 맵 — Z = f · B / d</a:t>
             </a:r>
           </a:p>
           <a:p>
@@ -3820,7 +4517,7 @@
               </a:lnSpc>
             </a:pPr>
             <a:r>
-              <a:rPr sz="950" b="0">
+              <a:rPr sz="1000" b="0">
                 <a:solidFill>
                   <a:srgbClr val="171717"/>
                 </a:solidFill>
@@ -3828,7 +4525,7 @@
                 <a:ea typeface="Pretendard Medium"/>
                 <a:cs typeface="Pretendard Medium"/>
               </a:rPr>
-              <a:t>⑤ X = (u−cx)·Z/f,  Y = (v−cy)·Z/f     ← 포인트 클라우드</a:t>
+              <a:t>⑤ 포인트 클라우드 — X = (u−cx)·Z/f,  Y = (v−cy)·Z/f</a:t>
             </a:r>
           </a:p>
         </p:txBody>
@@ -3931,7 +4628,7 @@
                 <a:ea typeface="Cascadia Mono"/>
                 <a:cs typeface="Cascadia Mono"/>
               </a:rPr>
-              <a:t>02 / VALIDATION ON EXACT GROUND TRUTH</a:t>
+              <a:t>02 / 검증</a:t>
             </a:r>
           </a:p>
         </p:txBody>
@@ -3972,7 +4669,7 @@
                 <a:ea typeface="Pretendard SemiBold"/>
                 <a:cs typeface="Pretendard SemiBold"/>
               </a:rPr>
-              <a:t>정답이 있는 조건에서 먼저 검증</a:t>
+              <a:t>정답 깊이 폭 0.90 m 를 0.92 m 로 복원</a:t>
             </a:r>
           </a:p>
         </p:txBody>
@@ -4013,7 +4710,7 @@
                 <a:ea typeface="Pretendard"/>
                 <a:cs typeface="Pretendard"/>
               </a:rPr>
-              <a:t>구·직육면체의 광선 교차를 해석적으로 풀어 정답 깊이에 렌더링 오차가 없다 · 남는 오차는 전부 정합 알고리즘에서 온다</a:t>
+              <a:t>구와 직육면체로 위성을 세우고 광선 교차를 해석적으로 풀면 정답 깊이에 오차가 없다 · 남는 오차는 전부 정합에서 온다</a:t>
             </a:r>
           </a:p>
         </p:txBody>
@@ -4123,8 +4820,8 @@
         </p:blipFill>
         <p:spPr>
           <a:xfrm>
-            <a:off x="795528" y="1878300"/>
-            <a:ext cx="10597896" cy="2241862"/>
+            <a:off x="795528" y="1821688"/>
+            <a:ext cx="10597896" cy="2355088"/>
           </a:xfrm>
           <a:prstGeom prst="rect">
             <a:avLst/>
@@ -4133,59 +4830,18 @@
       </p:pic>
       <p:sp>
         <p:nvSpPr>
-          <p:cNvPr id="9" name="TextBox 8"/>
-          <p:cNvSpPr txBox="1"/>
-          <p:nvPr/>
-        </p:nvSpPr>
-        <p:spPr>
-          <a:xfrm>
-            <a:off x="658368" y="4434840"/>
-            <a:ext cx="10872216" cy="182880"/>
-          </a:xfrm>
-          <a:prstGeom prst="rect">
-            <a:avLst/>
-          </a:prstGeom>
-          <a:noFill/>
-        </p:spPr>
-        <p:txBody>
-          <a:bodyPr wrap="square" lIns="0" rIns="0" tIns="0" bIns="0">
-            <a:spAutoFit/>
-          </a:bodyPr>
-          <a:lstStyle/>
-          <a:p>
-            <a:pPr algn="l">
-              <a:lnSpc>
-                <a:spcPct val="135000"/>
-              </a:lnSpc>
-            </a:pPr>
-            <a:r>
-              <a:rPr sz="850" b="0">
-                <a:solidFill>
-                  <a:srgbClr val="8F8F8F"/>
-                </a:solidFill>
-                <a:latin typeface="Cascadia Mono"/>
-                <a:ea typeface="Cascadia Mono"/>
-                <a:cs typeface="Cascadia Mono"/>
-              </a:rPr>
-              <a:t>STEREO PAIR · DISPARITY · GROUND TRUTH / STEREO / EXAMPLE CODE DEPTH</a:t>
-            </a:r>
-          </a:p>
-        </p:txBody>
-      </p:sp>
-      <p:sp>
-        <p:nvSpPr>
-          <p:cNvPr id="10" name="Rounded Rectangle 9"/>
+          <p:cNvPr id="9" name="Rounded Rectangle 8"/>
           <p:cNvSpPr/>
           <p:nvPr/>
         </p:nvSpPr>
         <p:spPr>
           <a:xfrm>
-            <a:off x="658368" y="4681728"/>
-            <a:ext cx="5358384" cy="1581912"/>
+            <a:off x="658368" y="4590288"/>
+            <a:ext cx="5358384" cy="1673352"/>
           </a:xfrm>
           <a:prstGeom prst="roundRect">
             <a:avLst>
-              <a:gd name="adj" fmla="val 7225"/>
+              <a:gd name="adj" fmla="val 6830"/>
             </a:avLst>
           </a:prstGeom>
           <a:solidFill>
@@ -4222,13 +4878,13 @@
       </p:sp>
       <p:sp>
         <p:nvSpPr>
-          <p:cNvPr id="11" name="TextBox 10"/>
+          <p:cNvPr id="10" name="TextBox 9"/>
           <p:cNvSpPr txBox="1"/>
           <p:nvPr/>
         </p:nvSpPr>
         <p:spPr>
           <a:xfrm>
-            <a:off x="896112" y="4855464"/>
+            <a:off x="896112" y="4764024"/>
             <a:ext cx="4882896" cy="219456"/>
           </a:xfrm>
           <a:prstGeom prst="rect">
@@ -4256,21 +4912,21 @@
                 <a:ea typeface="Pretendard SemiBold"/>
                 <a:cs typeface="Pretendard SemiBold"/>
               </a:rPr>
-              <a:t>정량 결과</a:t>
-            </a:r>
-          </a:p>
-        </p:txBody>
-      </p:sp>
-      <p:sp>
-        <p:nvSpPr>
-          <p:cNvPr id="12" name="TextBox 11"/>
+              <a:t>같은 영상, 두 가지 방법</a:t>
+            </a:r>
+          </a:p>
+        </p:txBody>
+      </p:sp>
+      <p:sp>
+        <p:nvSpPr>
+          <p:cNvPr id="11" name="TextBox 10"/>
           <p:cNvSpPr txBox="1"/>
           <p:nvPr/>
         </p:nvSpPr>
         <p:spPr>
           <a:xfrm>
-            <a:off x="896112" y="5102352"/>
-            <a:ext cx="4882896" cy="978407"/>
+            <a:off x="896112" y="5010912"/>
+            <a:ext cx="4882896" cy="1069848"/>
           </a:xfrm>
           <a:prstGeom prst="rect">
             <a:avLst/>
@@ -4289,15 +4945,15 @@
               </a:lnSpc>
             </a:pPr>
             <a:r>
-              <a:rPr sz="850" b="0">
+              <a:rPr sz="1000" b="0">
                 <a:solidFill>
                   <a:srgbClr val="4D4D4D"/>
                 </a:solidFill>
-                <a:latin typeface="Cascadia Mono"/>
-                <a:ea typeface="Cascadia Mono"/>
-                <a:cs typeface="Cascadia Mono"/>
+                <a:latin typeface="Pretendard"/>
+                <a:ea typeface="Pretendard"/>
+                <a:cs typeface="Pretendard"/>
               </a:rPr>
-              <a:t>베이스라인 0.40 m · 기대 시차 102 px · 분해능 4.9 cm/px</a:t>
+              <a:t>왼쪽·오른쪽 영상을 만들고 두 방법으로 깊이를 구했습니다.</a:t>
             </a:r>
           </a:p>
           <a:p>
@@ -4307,15 +4963,15 @@
               </a:lnSpc>
             </a:pPr>
             <a:r>
-              <a:rPr sz="850" b="0">
+              <a:rPr sz="1000" b="0">
                 <a:solidFill>
                   <a:srgbClr val="4D4D4D"/>
                 </a:solidFill>
-                <a:latin typeface="Cascadia Mono"/>
-                <a:ea typeface="Cascadia Mono"/>
-                <a:cs typeface="Cascadia Mono"/>
+                <a:latin typeface="Pretendard"/>
+                <a:ea typeface="Pretendard"/>
+                <a:cs typeface="Pretendard"/>
               </a:rPr>
-              <a:t>                RMSE     중앙값    5cm이내   깊이폭</a:t>
+              <a:t>과제 예시 코드에는 정답에 맞춘 최적 정렬까지 해 줬습니다.</a:t>
             </a:r>
           </a:p>
           <a:p>
@@ -4325,15 +4981,15 @@
               </a:lnSpc>
             </a:pPr>
             <a:r>
-              <a:rPr sz="850" b="0">
+              <a:rPr sz="400" b="0">
                 <a:solidFill>
                   <a:srgbClr val="4D4D4D"/>
                 </a:solidFill>
-                <a:latin typeface="Cascadia Mono"/>
-                <a:ea typeface="Cascadia Mono"/>
-                <a:cs typeface="Cascadia Mono"/>
+                <a:latin typeface="Pretendard"/>
+                <a:ea typeface="Pretendard"/>
+                <a:cs typeface="Pretendard"/>
               </a:rPr>
-              <a:t>스테레오        0.0404   0.0104    96.1%   0.915</a:t>
+              <a:t/>
             </a:r>
           </a:p>
           <a:p>
@@ -4343,7 +4999,7 @@
               </a:lnSpc>
             </a:pPr>
             <a:r>
-              <a:rPr sz="850" b="0">
+              <a:rPr sz="950" b="0">
                 <a:solidFill>
                   <a:srgbClr val="4D4D4D"/>
                 </a:solidFill>
@@ -4351,7 +5007,7 @@
                 <a:ea typeface="Cascadia Mono"/>
                 <a:cs typeface="Cascadia Mono"/>
               </a:rPr>
-              <a:t>과제 예시       0.1287   0.0717    33.5%   0.017</a:t>
+              <a:t>                깊이 폭    오차 중앙값   5cm 이내</a:t>
             </a:r>
           </a:p>
           <a:p>
@@ -4363,31 +5019,67 @@
             <a:r>
               <a:rPr sz="950" b="0">
                 <a:solidFill>
-                  <a:srgbClr val="171717"/>
-                </a:solidFill>
-                <a:latin typeface="Pretendard Medium"/>
-                <a:ea typeface="Pretendard Medium"/>
-                <a:cs typeface="Pretendard Medium"/>
+                  <a:srgbClr val="4D4D4D"/>
+                </a:solidFill>
+                <a:latin typeface="Cascadia Mono"/>
+                <a:ea typeface="Cascadia Mono"/>
+                <a:cs typeface="Cascadia Mono"/>
               </a:rPr>
-              <a:t>정답 깊이폭 0.898 m — 스테레오는 0.915 m 로 되살리고, 예시 코드는 0.017 m 로 평면이 됩니다.</a:t>
-            </a:r>
-          </a:p>
-        </p:txBody>
-      </p:sp>
-      <p:sp>
-        <p:nvSpPr>
-          <p:cNvPr id="13" name="Rounded Rectangle 12"/>
+              <a:t>정  답          0.898 m         —          —</a:t>
+            </a:r>
+          </a:p>
+          <a:p>
+            <a:pPr algn="l">
+              <a:lnSpc>
+                <a:spcPct val="130000"/>
+              </a:lnSpc>
+            </a:pPr>
+            <a:r>
+              <a:rPr sz="950" b="0">
+                <a:solidFill>
+                  <a:srgbClr val="4D4D4D"/>
+                </a:solidFill>
+                <a:latin typeface="Cascadia Mono"/>
+                <a:ea typeface="Cascadia Mono"/>
+                <a:cs typeface="Cascadia Mono"/>
+              </a:rPr>
+              <a:t>스테레오        0.915 m        1.0 cm      96.1%</a:t>
+            </a:r>
+          </a:p>
+          <a:p>
+            <a:pPr algn="l">
+              <a:lnSpc>
+                <a:spcPct val="130000"/>
+              </a:lnSpc>
+            </a:pPr>
+            <a:r>
+              <a:rPr sz="950" b="0">
+                <a:solidFill>
+                  <a:srgbClr val="4D4D4D"/>
+                </a:solidFill>
+                <a:latin typeface="Cascadia Mono"/>
+                <a:ea typeface="Cascadia Mono"/>
+                <a:cs typeface="Cascadia Mono"/>
+              </a:rPr>
+              <a:t>과제 예시       0.017 m        7.2 cm      33.5%</a:t>
+            </a:r>
+          </a:p>
+        </p:txBody>
+      </p:sp>
+      <p:sp>
+        <p:nvSpPr>
+          <p:cNvPr id="12" name="Rounded Rectangle 11"/>
           <p:cNvSpPr/>
           <p:nvPr/>
         </p:nvSpPr>
         <p:spPr>
           <a:xfrm>
-            <a:off x="6364224" y="4681728"/>
-            <a:ext cx="5166360" cy="1581912"/>
+            <a:off x="6364224" y="4590288"/>
+            <a:ext cx="5166360" cy="1673352"/>
           </a:xfrm>
           <a:prstGeom prst="roundRect">
             <a:avLst>
-              <a:gd name="adj" fmla="val 7225"/>
+              <a:gd name="adj" fmla="val 6830"/>
             </a:avLst>
           </a:prstGeom>
           <a:solidFill>
@@ -4424,13 +5116,13 @@
       </p:sp>
       <p:sp>
         <p:nvSpPr>
-          <p:cNvPr id="14" name="TextBox 13"/>
+          <p:cNvPr id="13" name="TextBox 12"/>
           <p:cNvSpPr txBox="1"/>
           <p:nvPr/>
         </p:nvSpPr>
         <p:spPr>
           <a:xfrm>
-            <a:off x="6601968" y="4855464"/>
+            <a:off x="6601968" y="4764024"/>
             <a:ext cx="4690872" cy="219456"/>
           </a:xfrm>
           <a:prstGeom prst="rect">
@@ -4458,21 +5150,21 @@
                 <a:ea typeface="Pretendard SemiBold"/>
                 <a:cs typeface="Pretendard SemiBold"/>
               </a:rPr>
-              <a:t>Unit Test 65개</a:t>
-            </a:r>
-          </a:p>
-        </p:txBody>
-      </p:sp>
-      <p:sp>
-        <p:nvSpPr>
-          <p:cNvPr id="15" name="TextBox 14"/>
+              <a:t>Unit Test 65개로 수식을 검증</a:t>
+            </a:r>
+          </a:p>
+        </p:txBody>
+      </p:sp>
+      <p:sp>
+        <p:nvSpPr>
+          <p:cNvPr id="14" name="TextBox 13"/>
           <p:cNvSpPr txBox="1"/>
           <p:nvPr/>
         </p:nvSpPr>
         <p:spPr>
           <a:xfrm>
-            <a:off x="6601968" y="5102352"/>
-            <a:ext cx="4690872" cy="978407"/>
+            <a:off x="6601968" y="5010912"/>
+            <a:ext cx="4690872" cy="1069848"/>
           </a:xfrm>
           <a:prstGeom prst="rect">
             <a:avLst/>
@@ -4491,15 +5183,15 @@
               </a:lnSpc>
             </a:pPr>
             <a:r>
-              <a:rPr sz="950" b="0">
-                <a:solidFill>
-                  <a:srgbClr val="171717"/>
-                </a:solidFill>
-                <a:latin typeface="Pretendard Medium"/>
-                <a:ea typeface="Pretendard Medium"/>
-                <a:cs typeface="Pretendard Medium"/>
+              <a:rPr sz="1000" b="0">
+                <a:solidFill>
+                  <a:srgbClr val="4D4D4D"/>
+                </a:solidFill>
+                <a:latin typeface="Pretendard"/>
+                <a:ea typeface="Pretendard"/>
+                <a:cs typeface="Pretendard"/>
               </a:rPr>
-              <a:t>해석해 — Z = f·B/d 를 1e-12 까지, 구의 중심 깊이 = 거리−반지름 을 1e-9 까지</a:t>
+              <a:t>출력 크기와 자료형만 보면 수식이 틀려도 통과합니다.</a:t>
             </a:r>
           </a:p>
           <a:p>
@@ -4509,15 +5201,15 @@
               </a:lnSpc>
             </a:pPr>
             <a:r>
-              <a:rPr sz="950" b="0">
-                <a:solidFill>
-                  <a:srgbClr val="171717"/>
-                </a:solidFill>
-                <a:latin typeface="Pretendard Medium"/>
-                <a:ea typeface="Pretendard Medium"/>
-                <a:cs typeface="Pretendard Medium"/>
+              <a:rPr sz="1000" b="0">
+                <a:solidFill>
+                  <a:srgbClr val="4D4D4D"/>
+                </a:solidFill>
+                <a:latin typeface="Pretendard"/>
+                <a:ea typeface="Pretendard"/>
+                <a:cs typeface="Pretendard"/>
               </a:rPr>
-              <a:t>불변식 — p_j = R_ij·p_i + t_ij 성립, B와 d를 함께 2배 하면 Z 불변</a:t>
+              <a:t>손으로 풀 수 있는 조건을 만들어 수치까지 확인했습니다.</a:t>
             </a:r>
           </a:p>
           <a:p>
@@ -4527,15 +5219,15 @@
               </a:lnSpc>
             </a:pPr>
             <a:r>
-              <a:rPr sz="950" b="0">
-                <a:solidFill>
-                  <a:srgbClr val="171717"/>
-                </a:solidFill>
-                <a:latin typeface="Pretendard Medium"/>
-                <a:ea typeface="Pretendard Medium"/>
-                <a:cs typeface="Pretendard Medium"/>
+              <a:rPr sz="400" b="0">
+                <a:solidFill>
+                  <a:srgbClr val="4D4D4D"/>
+                </a:solidFill>
+                <a:latin typeface="Pretendard"/>
+                <a:ea typeface="Pretendard"/>
+                <a:cs typeface="Pretendard"/>
               </a:rPr>
-              <a:t>실패 특성화 — 같은 거리·다른 반사율이 4배 다른 깊이로 읽히는 것,</a:t>
+              <a:t/>
             </a:r>
           </a:p>
           <a:p>
@@ -4545,15 +5237,15 @@
               </a:lnSpc>
             </a:pPr>
             <a:r>
-              <a:rPr sz="950" b="0">
-                <a:solidFill>
-                  <a:srgbClr val="4D4D4D"/>
-                </a:solidFill>
-                <a:latin typeface="Pretendard"/>
-                <a:ea typeface="Pretendard"/>
-                <a:cs typeface="Pretendard"/>
+              <a:rPr sz="1000" b="0">
+                <a:solidFill>
+                  <a:srgbClr val="171717"/>
+                </a:solidFill>
+                <a:latin typeface="Pretendard Medium"/>
+                <a:ea typeface="Pretendard Medium"/>
+                <a:cs typeface="Pretendard Medium"/>
               </a:rPr>
-              <a:t>                 앞면이 그늘이면 깊이 구조가 뭉개지는 것</a:t>
+              <a:t>해석해 — Z = f·B/d 를 1e-12 까지 대조</a:t>
             </a:r>
           </a:p>
           <a:p>
@@ -4563,7 +5255,43 @@
               </a:lnSpc>
             </a:pPr>
             <a:r>
-              <a:rPr sz="950" b="0">
+              <a:rPr sz="1000" b="0">
+                <a:solidFill>
+                  <a:srgbClr val="171717"/>
+                </a:solidFill>
+                <a:latin typeface="Pretendard Medium"/>
+                <a:ea typeface="Pretendard Medium"/>
+                <a:cs typeface="Pretendard Medium"/>
+              </a:rPr>
+              <a:t>불변식 — B와 d를 함께 2배 하면 Z 는 그대로</a:t>
+            </a:r>
+          </a:p>
+          <a:p>
+            <a:pPr algn="l">
+              <a:lnSpc>
+                <a:spcPct val="130000"/>
+              </a:lnSpc>
+            </a:pPr>
+            <a:r>
+              <a:rPr sz="1000" b="0">
+                <a:solidFill>
+                  <a:srgbClr val="171717"/>
+                </a:solidFill>
+                <a:latin typeface="Pretendard Medium"/>
+                <a:ea typeface="Pretendard Medium"/>
+                <a:cs typeface="Pretendard Medium"/>
+              </a:rPr>
+              <a:t>실패 특성화 — 같은 거리라도 반사율이 다르면 4배 다른 깊이</a:t>
+            </a:r>
+          </a:p>
+          <a:p>
+            <a:pPr algn="l">
+              <a:lnSpc>
+                <a:spcPct val="130000"/>
+              </a:lnSpc>
+            </a:pPr>
+            <a:r>
+              <a:rPr sz="1000" b="0">
                 <a:solidFill>
                   <a:srgbClr val="4D4D4D"/>
                 </a:solidFill>
@@ -4674,7 +5402,7 @@
                 <a:ea typeface="Cascadia Mono"/>
                 <a:cs typeface="Cascadia Mono"/>
               </a:rPr>
-              <a:t>03 / RESULTS &amp; LIMITS</a:t>
+              <a:t>03 / 결과와 한계</a:t>
             </a:r>
           </a:p>
         </p:txBody>
@@ -4715,7 +5443,7 @@
                 <a:ea typeface="Pretendard SemiBold"/>
                 <a:cs typeface="Pretendard SemiBold"/>
               </a:rPr>
-              <a:t>SPE3R 실측 결과와 한계</a:t>
+              <a:t>실제 위성 영상에서 깊이 오차 중앙값 0.9 cm</a:t>
             </a:r>
           </a:p>
         </p:txBody>
@@ -4756,7 +5484,7 @@
                 <a:ea typeface="Pretendard"/>
                 <a:cs typeface="Pretendard"/>
               </a:rPr>
-              <a:t>기준 깊이 = 동봉 메시 40만 점을 z-buffer 로 투영 · 대조군에는 정답에 대한 최적 아핀정렬을 적용해 유리한 조건을 부여</a:t>
+              <a:t>기준 깊이 = 동봉 메시 40만 점을 z-buffer 로 투영 · 대조군에는 정답에 맞춘 최적 정렬을 적용해 유리한 조건을 부여</a:t>
             </a:r>
           </a:p>
         </p:txBody>
@@ -4811,11 +5539,11 @@
         <p:spPr>
           <a:xfrm>
             <a:off x="658368" y="1627632"/>
-            <a:ext cx="10872216" cy="2743200"/>
+            <a:ext cx="10872216" cy="2331720"/>
           </a:xfrm>
           <a:prstGeom prst="roundRect">
             <a:avLst>
-              <a:gd name="adj" fmla="val 4166"/>
+              <a:gd name="adj" fmla="val 4901"/>
             </a:avLst>
           </a:prstGeom>
           <a:solidFill>
@@ -4852,7 +5580,7 @@
       </p:sp>
       <p:pic>
         <p:nvPicPr>
-          <p:cNvPr id="8" name="Picture 7" descr="04_pointclouds.png"/>
+          <p:cNvPr id="8" name="Picture 7" descr="03_spe3r_stereo.png"/>
           <p:cNvPicPr>
             <a:picLocks noChangeAspect="1"/>
           </p:cNvPicPr>
@@ -4866,8 +5594,8 @@
         </p:blipFill>
         <p:spPr>
           <a:xfrm>
-            <a:off x="2391155" y="1764792"/>
-            <a:ext cx="7406640" cy="2468880"/>
+            <a:off x="1465326" y="1764792"/>
+            <a:ext cx="9258300" cy="2057400"/>
           </a:xfrm>
           <a:prstGeom prst="rect">
             <a:avLst/>
@@ -4876,59 +5604,18 @@
       </p:pic>
       <p:sp>
         <p:nvSpPr>
-          <p:cNvPr id="9" name="TextBox 8"/>
-          <p:cNvSpPr txBox="1"/>
-          <p:nvPr/>
-        </p:nvSpPr>
-        <p:spPr>
-          <a:xfrm>
-            <a:off x="658368" y="4434840"/>
-            <a:ext cx="10872216" cy="182880"/>
-          </a:xfrm>
-          <a:prstGeom prst="rect">
-            <a:avLst/>
-          </a:prstGeom>
-          <a:noFill/>
-        </p:spPr>
-        <p:txBody>
-          <a:bodyPr wrap="square" lIns="0" rIns="0" tIns="0" bIns="0">
-            <a:spAutoFit/>
-          </a:bodyPr>
-          <a:lstStyle/>
-          <a:p>
-            <a:pPr algn="l">
-              <a:lnSpc>
-                <a:spcPct val="135000"/>
-              </a:lnSpc>
-            </a:pPr>
-            <a:r>
-              <a:rPr sz="850" b="0">
-                <a:solidFill>
-                  <a:srgbClr val="8F8F8F"/>
-                </a:solidFill>
-                <a:latin typeface="Cascadia Mono"/>
-                <a:ea typeface="Cascadia Mono"/>
-                <a:cs typeface="Cascadia Mono"/>
-              </a:rPr>
-              <a:t>GROUND TRUTH MESH · STEREO DEPTH → 3D (SINGLE VIEW) · EXAMPLE CODE</a:t>
-            </a:r>
-          </a:p>
-        </p:txBody>
-      </p:sp>
-      <p:sp>
-        <p:nvSpPr>
-          <p:cNvPr id="10" name="Rounded Rectangle 9"/>
+          <p:cNvPr id="9" name="Rounded Rectangle 8"/>
           <p:cNvSpPr/>
           <p:nvPr/>
         </p:nvSpPr>
         <p:spPr>
           <a:xfrm>
-            <a:off x="658368" y="4681728"/>
-            <a:ext cx="5358384" cy="1581912"/>
+            <a:off x="658368" y="4169663"/>
+            <a:ext cx="6053328" cy="2093976"/>
           </a:xfrm>
           <a:prstGeom prst="roundRect">
             <a:avLst>
-              <a:gd name="adj" fmla="val 7225"/>
+              <a:gd name="adj" fmla="val 5458"/>
             </a:avLst>
           </a:prstGeom>
           <a:solidFill>
@@ -4965,14 +5652,14 @@
       </p:sp>
       <p:sp>
         <p:nvSpPr>
-          <p:cNvPr id="11" name="TextBox 10"/>
+          <p:cNvPr id="10" name="TextBox 9"/>
           <p:cNvSpPr txBox="1"/>
           <p:nvPr/>
         </p:nvSpPr>
         <p:spPr>
           <a:xfrm>
-            <a:off x="896112" y="4855464"/>
-            <a:ext cx="4882896" cy="219456"/>
+            <a:off x="896112" y="4343400"/>
+            <a:ext cx="5577840" cy="219456"/>
           </a:xfrm>
           <a:prstGeom prst="rect">
             <a:avLst/>
@@ -5006,14 +5693,14 @@
       </p:sp>
       <p:sp>
         <p:nvSpPr>
-          <p:cNvPr id="12" name="TextBox 11"/>
+          <p:cNvPr id="11" name="TextBox 10"/>
           <p:cNvSpPr txBox="1"/>
           <p:nvPr/>
         </p:nvSpPr>
         <p:spPr>
           <a:xfrm>
-            <a:off x="896112" y="5102352"/>
-            <a:ext cx="4882896" cy="978407"/>
+            <a:off x="896112" y="4590288"/>
+            <a:ext cx="5577840" cy="1490472"/>
           </a:xfrm>
           <a:prstGeom prst="rect">
             <a:avLst/>
@@ -5032,7 +5719,7 @@
               </a:lnSpc>
             </a:pPr>
             <a:r>
-              <a:rPr sz="850" b="0">
+              <a:rPr sz="950" b="0">
                 <a:solidFill>
                   <a:srgbClr val="4D4D4D"/>
                 </a:solidFill>
@@ -5040,7 +5727,7 @@
                 <a:ea typeface="Cascadia Mono"/>
                 <a:cs typeface="Cascadia Mono"/>
               </a:rPr>
-              <a:t>후보 20쌍 → 복원 성공 5쌍 → 오차 10cm 이내 3쌍</a:t>
+              <a:t>                RMSE      오차 중앙값   5cm 이내</a:t>
             </a:r>
           </a:p>
           <a:p>
@@ -5050,7 +5737,7 @@
               </a:lnSpc>
             </a:pPr>
             <a:r>
-              <a:rPr sz="850" b="0">
+              <a:rPr sz="950" b="0">
                 <a:solidFill>
                   <a:srgbClr val="4D4D4D"/>
                 </a:solidFill>
@@ -5058,7 +5745,7 @@
                 <a:ea typeface="Cascadia Mono"/>
                 <a:cs typeface="Cascadia Mono"/>
               </a:rPr>
-              <a:t>                RMSE     중앙값    5cm이내</a:t>
+              <a:t>스테레오        0.0677 m     0.9 cm      90.3%</a:t>
             </a:r>
           </a:p>
           <a:p>
@@ -5068,7 +5755,7 @@
               </a:lnSpc>
             </a:pPr>
             <a:r>
-              <a:rPr sz="850" b="0">
+              <a:rPr sz="950" b="0">
                 <a:solidFill>
                   <a:srgbClr val="4D4D4D"/>
                 </a:solidFill>
@@ -5076,7 +5763,7 @@
                 <a:ea typeface="Cascadia Mono"/>
                 <a:cs typeface="Cascadia Mono"/>
               </a:rPr>
-              <a:t>스테레오        0.0677   0.0093    90.3%</a:t>
+              <a:t>과제 예시       0.0893 m     4.9 cm      50.8%</a:t>
             </a:r>
           </a:p>
           <a:p>
@@ -5086,15 +5773,15 @@
               </a:lnSpc>
             </a:pPr>
             <a:r>
-              <a:rPr sz="850" b="0">
+              <a:rPr sz="400" b="0">
                 <a:solidFill>
                   <a:srgbClr val="4D4D4D"/>
                 </a:solidFill>
-                <a:latin typeface="Cascadia Mono"/>
-                <a:ea typeface="Cascadia Mono"/>
-                <a:cs typeface="Cascadia Mono"/>
+                <a:latin typeface="Pretendard"/>
+                <a:ea typeface="Pretendard"/>
+                <a:cs typeface="Pretendard"/>
               </a:rPr>
-              <a:t>과제 예시       0.0893   0.0485    50.8%</a:t>
+              <a:t/>
             </a:r>
           </a:p>
           <a:p>
@@ -5104,7 +5791,7 @@
               </a:lnSpc>
             </a:pPr>
             <a:r>
-              <a:rPr sz="950" b="0">
+              <a:rPr sz="1000" b="0">
                 <a:solidFill>
                   <a:srgbClr val="171717"/>
                 </a:solidFill>
@@ -5112,7 +5799,7 @@
                 <a:ea typeface="Pretendard Medium"/>
                 <a:cs typeface="Pretendard Medium"/>
               </a:rPr>
-              <a:t>포인트 클라우드 4,998점 · 메시 대비 Chamfer 0.0120</a:t>
+              <a:t>포인트 클라우드 4,998점 · 메시 대비 Chamfer 0.0120  →</a:t>
             </a:r>
           </a:p>
           <a:p>
@@ -5122,7 +5809,7 @@
               </a:lnSpc>
             </a:pPr>
             <a:r>
-              <a:rPr sz="950" b="0">
+              <a:rPr sz="400" b="0">
                 <a:solidFill>
                   <a:srgbClr val="4D4D4D"/>
                 </a:solidFill>
@@ -5130,25 +5817,79 @@
                 <a:ea typeface="Pretendard"/>
                 <a:cs typeface="Pretendard"/>
               </a:rPr>
-              <a:t>예시 코드는 최적 정렬 스케일 -0.153 — 관계가 뒤집힙니다.</a:t>
-            </a:r>
-          </a:p>
-        </p:txBody>
-      </p:sp>
-      <p:sp>
-        <p:nvSpPr>
-          <p:cNvPr id="13" name="Rounded Rectangle 12"/>
+              <a:t/>
+            </a:r>
+          </a:p>
+          <a:p>
+            <a:pPr algn="l">
+              <a:lnSpc>
+                <a:spcPct val="130000"/>
+              </a:lnSpc>
+            </a:pPr>
+            <a:r>
+              <a:rPr sz="1000" b="0">
+                <a:solidFill>
+                  <a:srgbClr val="4D4D4D"/>
+                </a:solidFill>
+                <a:latin typeface="Pretendard"/>
+                <a:ea typeface="Pretendard"/>
+                <a:cs typeface="Pretendard"/>
+              </a:rPr>
+              <a:t>한계 — 조건을 만족하는 쌍이 후보 20개 중 3개, 유효화소 59%,</a:t>
+            </a:r>
+          </a:p>
+          <a:p>
+            <a:pPr algn="l">
+              <a:lnSpc>
+                <a:spcPct val="130000"/>
+              </a:lnSpc>
+            </a:pPr>
+            <a:r>
+              <a:rPr sz="1000" b="0">
+                <a:solidFill>
+                  <a:srgbClr val="4D4D4D"/>
+                </a:solidFill>
+                <a:latin typeface="Pretendard"/>
+                <a:ea typeface="Pretendard"/>
+                <a:cs typeface="Pretendard"/>
+              </a:rPr>
+              <a:t>단일 시점이라 뒷면은 복원 불가, 정답 자세를 그대로 사용,</a:t>
+            </a:r>
+          </a:p>
+          <a:p>
+            <a:pPr algn="l">
+              <a:lnSpc>
+                <a:spcPct val="130000"/>
+              </a:lnSpc>
+            </a:pPr>
+            <a:r>
+              <a:rPr sz="1000" b="0">
+                <a:solidFill>
+                  <a:srgbClr val="4D4D4D"/>
+                </a:solidFill>
+                <a:latin typeface="Pretendard"/>
+                <a:ea typeface="Pretendard"/>
+                <a:cs typeface="Pretendard"/>
+              </a:rPr>
+              <a:t>깊이 분해능 하한 6.8 cm/px (dZ = Z²/fB)</a:t>
+            </a:r>
+          </a:p>
+        </p:txBody>
+      </p:sp>
+      <p:sp>
+        <p:nvSpPr>
+          <p:cNvPr id="12" name="Rounded Rectangle 11"/>
           <p:cNvSpPr/>
           <p:nvPr/>
         </p:nvSpPr>
         <p:spPr>
           <a:xfrm>
-            <a:off x="6364224" y="4681728"/>
-            <a:ext cx="5166360" cy="1581912"/>
+            <a:off x="6931152" y="4169663"/>
+            <a:ext cx="4599432" cy="2093976"/>
           </a:xfrm>
           <a:prstGeom prst="roundRect">
             <a:avLst>
-              <a:gd name="adj" fmla="val 7225"/>
+              <a:gd name="adj" fmla="val 5458"/>
             </a:avLst>
           </a:prstGeom>
           <a:solidFill>
@@ -5183,178 +5924,30 @@
           </a:p>
         </p:txBody>
       </p:sp>
-      <p:sp>
-        <p:nvSpPr>
-          <p:cNvPr id="14" name="TextBox 13"/>
-          <p:cNvSpPr txBox="1"/>
+      <p:pic>
+        <p:nvPicPr>
+          <p:cNvPr id="13" name="Picture 12" descr="04_pointclouds.png"/>
+          <p:cNvPicPr>
+            <a:picLocks noChangeAspect="1"/>
+          </p:cNvPicPr>
           <p:nvPr/>
-        </p:nvSpPr>
-        <p:spPr>
-          <a:xfrm>
-            <a:off x="6601968" y="4855464"/>
-            <a:ext cx="4690872" cy="219456"/>
+        </p:nvPicPr>
+        <p:blipFill>
+          <a:blip r:embed="rId3"/>
+          <a:stretch>
+            <a:fillRect/>
+          </a:stretch>
+        </p:blipFill>
+        <p:spPr>
+          <a:xfrm>
+            <a:off x="7068312" y="4647558"/>
+            <a:ext cx="4325112" cy="1138187"/>
           </a:xfrm>
           <a:prstGeom prst="rect">
             <a:avLst/>
           </a:prstGeom>
-          <a:noFill/>
-        </p:spPr>
-        <p:txBody>
-          <a:bodyPr wrap="square" lIns="0" rIns="0" tIns="0" bIns="0">
-            <a:spAutoFit/>
-          </a:bodyPr>
-          <a:lstStyle/>
-          <a:p>
-            <a:pPr algn="l">
-              <a:lnSpc>
-                <a:spcPct val="135000"/>
-              </a:lnSpc>
-            </a:pPr>
-            <a:r>
-              <a:rPr sz="1050" b="0">
-                <a:solidFill>
-                  <a:srgbClr val="171717"/>
-                </a:solidFill>
-                <a:latin typeface="Pretendard SemiBold"/>
-                <a:ea typeface="Pretendard SemiBold"/>
-                <a:cs typeface="Pretendard SemiBold"/>
-              </a:rPr>
-              <a:t>정합을 좌우하는 요인 · 한계</a:t>
-            </a:r>
-          </a:p>
-        </p:txBody>
-      </p:sp>
-      <p:sp>
-        <p:nvSpPr>
-          <p:cNvPr id="15" name="TextBox 14"/>
-          <p:cNvSpPr txBox="1"/>
-          <p:nvPr/>
-        </p:nvSpPr>
-        <p:spPr>
-          <a:xfrm>
-            <a:off x="6601968" y="5102352"/>
-            <a:ext cx="4690872" cy="978407"/>
-          </a:xfrm>
-          <a:prstGeom prst="rect">
-            <a:avLst/>
-          </a:prstGeom>
-          <a:noFill/>
-        </p:spPr>
-        <p:txBody>
-          <a:bodyPr wrap="square" lIns="0" rIns="0" tIns="0" bIns="0">
-            <a:spAutoFit/>
-          </a:bodyPr>
-          <a:lstStyle/>
-          <a:p>
-            <a:pPr algn="l">
-              <a:lnSpc>
-                <a:spcPct val="130000"/>
-              </a:lnSpc>
-            </a:pPr>
-            <a:r>
-              <a:rPr sz="950" b="0">
-                <a:solidFill>
-                  <a:srgbClr val="171717"/>
-                </a:solidFill>
-                <a:latin typeface="Pretendard Medium"/>
-                <a:ea typeface="Pretendard Medium"/>
-                <a:cs typeface="Pretendard Medium"/>
-              </a:rPr>
-              <a:t>① 표면 무늬 — 조명만 뒤집어 앞면을 그늘에 넣는 통제 실험</a:t>
-            </a:r>
-          </a:p>
-          <a:p>
-            <a:pPr algn="l">
-              <a:lnSpc>
-                <a:spcPct val="130000"/>
-              </a:lnSpc>
-            </a:pPr>
-            <a:r>
-              <a:rPr sz="950" b="0">
-                <a:solidFill>
-                  <a:srgbClr val="4D4D4D"/>
-                </a:solidFill>
-                <a:latin typeface="Pretendard"/>
-                <a:ea typeface="Pretendard"/>
-                <a:cs typeface="Pretendard"/>
-              </a:rPr>
-              <a:t>     깊이폭 0.915 → 0.572 m. 블록 크기를 바꿔도 회복되지 않습니다.</a:t>
-            </a:r>
-          </a:p>
-          <a:p>
-            <a:pPr algn="l">
-              <a:lnSpc>
-                <a:spcPct val="130000"/>
-              </a:lnSpc>
-            </a:pPr>
-            <a:r>
-              <a:rPr sz="950" b="0">
-                <a:solidFill>
-                  <a:srgbClr val="171717"/>
-                </a:solidFill>
-                <a:latin typeface="Pretendard Medium"/>
-                <a:ea typeface="Pretendard Medium"/>
-                <a:cs typeface="Pretendard Medium"/>
-              </a:rPr>
-              <a:t>② 이상치 필터 — filterSpeckles + 중앙값 3×3</a:t>
-            </a:r>
-          </a:p>
-          <a:p>
-            <a:pPr algn="l">
-              <a:lnSpc>
-                <a:spcPct val="130000"/>
-              </a:lnSpc>
-            </a:pPr>
-            <a:r>
-              <a:rPr sz="950" b="0">
-                <a:solidFill>
-                  <a:srgbClr val="4D4D4D"/>
-                </a:solidFill>
-                <a:latin typeface="Pretendard"/>
-                <a:ea typeface="Pretendard"/>
-                <a:cs typeface="Pretendard"/>
-              </a:rPr>
-              <a:t>     RMSE 0.347 → 0.068 (중앙값은 0.0111 → 0.0093 로 거의 불변)</a:t>
-            </a:r>
-          </a:p>
-          <a:p>
-            <a:pPr algn="l">
-              <a:lnSpc>
-                <a:spcPct val="130000"/>
-              </a:lnSpc>
-            </a:pPr>
-            <a:r>
-              <a:rPr sz="950" b="0">
-                <a:solidFill>
-                  <a:srgbClr val="4D4D4D"/>
-                </a:solidFill>
-                <a:latin typeface="Pretendard"/>
-                <a:ea typeface="Pretendard"/>
-                <a:cs typeface="Pretendard"/>
-              </a:rPr>
-              <a:t>한계 — 1,000장 중 쓸 만한 쌍이 3개, 유효화소 59%, 단일 뷰라 뒷면은 복원 불가,</a:t>
-            </a:r>
-          </a:p>
-          <a:p>
-            <a:pPr algn="l">
-              <a:lnSpc>
-                <a:spcPct val="130000"/>
-              </a:lnSpc>
-            </a:pPr>
-            <a:r>
-              <a:rPr sz="950" b="0">
-                <a:solidFill>
-                  <a:srgbClr val="4D4D4D"/>
-                </a:solidFill>
-                <a:latin typeface="Pretendard"/>
-                <a:ea typeface="Pretendard"/>
-                <a:cs typeface="Pretendard"/>
-              </a:rPr>
-              <a:t>          정답 자세를 그대로 사용, 분해능 하한 6.8 cm/px (dZ = Z²/fB)</a:t>
-            </a:r>
-          </a:p>
-        </p:txBody>
-      </p:sp>
+        </p:spPr>
+      </p:pic>
     </p:spTree>
   </p:cSld>
   <p:clrMapOvr>
@@ -5681,4 +6274,324 @@
   </a:objectDefaults>
   <a:extraClrSchemeLst/>
 </a:theme>
+</file>
+
+<file path=ppt/theme/theme2.xml><?xml version="1.0" encoding="utf-8"?>
+<a:theme xmlns:a="http://schemas.openxmlformats.org/drawingml/2006/main" name="Office Theme">
+  <a:themeElements>
+    <a:clrScheme name="Office">
+      <a:dk1>
+        <a:sysClr val="windowText" lastClr="000000"/>
+      </a:dk1>
+      <a:lt1>
+        <a:sysClr val="window" lastClr="FFFFFF"/>
+      </a:lt1>
+      <a:dk2>
+        <a:srgbClr val="1F497D"/>
+      </a:dk2>
+      <a:lt2>
+        <a:srgbClr val="EEECE1"/>
+      </a:lt2>
+      <a:accent1>
+        <a:srgbClr val="4F81BD"/>
+      </a:accent1>
+      <a:accent2>
+        <a:srgbClr val="C0504D"/>
+      </a:accent2>
+      <a:accent3>
+        <a:srgbClr val="9BBB59"/>
+      </a:accent3>
+      <a:accent4>
+        <a:srgbClr val="8064A2"/>
+      </a:accent4>
+      <a:accent5>
+        <a:srgbClr val="4BACC6"/>
+      </a:accent5>
+      <a:accent6>
+        <a:srgbClr val="F79646"/>
+      </a:accent6>
+      <a:hlink>
+        <a:srgbClr val="0000FF"/>
+      </a:hlink>
+      <a:folHlink>
+        <a:srgbClr val="800080"/>
+      </a:folHlink>
+    </a:clrScheme>
+    <a:fontScheme name="Office">
+      <a:majorFont>
+        <a:latin typeface="Calibri"/>
+        <a:ea typeface=""/>
+        <a:cs typeface=""/>
+        <a:font script="Jpan" typeface="ＭＳ Ｐゴシック"/>
+        <a:font script="Hang" typeface="맑은 고딕"/>
+        <a:font script="Hans" typeface="宋体"/>
+        <a:font script="Hant" typeface="新細明體"/>
+        <a:font script="Arab" typeface="Times New Roman"/>
+        <a:font script="Hebr" typeface="Times New Roman"/>
+        <a:font script="Thai" typeface="Angsana New"/>
+        <a:font script="Ethi" typeface="Nyala"/>
+        <a:font script="Beng" typeface="Vrinda"/>
+        <a:font script="Gujr" typeface="Shruti"/>
+        <a:font script="Khmr" typeface="MoolBoran"/>
+        <a:font script="Knda" typeface="Tunga"/>
+        <a:font script="Guru" typeface="Raavi"/>
+        <a:font script="Cans" typeface="Euphemia"/>
+        <a:font script="Cher" typeface="Plantagenet Cherokee"/>
+        <a:font script="Yiii" typeface="Microsoft Yi Baiti"/>
+        <a:font script="Tibt" typeface="Microsoft Himalaya"/>
+        <a:font script="Thaa" typeface="MV Boli"/>
+        <a:font script="Deva" typeface="Mangal"/>
+        <a:font script="Telu" typeface="Gautami"/>
+        <a:font script="Taml" typeface="Latha"/>
+        <a:font script="Syrc" typeface="Estrangelo Edessa"/>
+        <a:font script="Orya" typeface="Kalinga"/>
+        <a:font script="Mlym" typeface="Kartika"/>
+        <a:font script="Laoo" typeface="DokChampa"/>
+        <a:font script="Sinh" typeface="Iskoola Pota"/>
+        <a:font script="Mong" typeface="Mongolian Baiti"/>
+        <a:font script="Viet" typeface="Times New Roman"/>
+        <a:font script="Uigh" typeface="Microsoft Uighur"/>
+        <a:font script="Geor" typeface="Sylfaen"/>
+      </a:majorFont>
+      <a:minorFont>
+        <a:latin typeface="Calibri"/>
+        <a:ea typeface=""/>
+        <a:cs typeface=""/>
+        <a:font script="Jpan" typeface="ＭＳ Ｐゴシック"/>
+        <a:font script="Hang" typeface="맑은 고딕"/>
+        <a:font script="Hans" typeface="宋体"/>
+        <a:font script="Hant" typeface="新細明體"/>
+        <a:font script="Arab" typeface="Arial"/>
+        <a:font script="Hebr" typeface="Arial"/>
+        <a:font script="Thai" typeface="Cordia New"/>
+        <a:font script="Ethi" typeface="Nyala"/>
+        <a:font script="Beng" typeface="Vrinda"/>
+        <a:font script="Gujr" typeface="Shruti"/>
+        <a:font script="Khmr" typeface="DaunPenh"/>
+        <a:font script="Knda" typeface="Tunga"/>
+        <a:font script="Guru" typeface="Raavi"/>
+        <a:font script="Cans" typeface="Euphemia"/>
+        <a:font script="Cher" typeface="Plantagenet Cherokee"/>
+        <a:font script="Yiii" typeface="Microsoft Yi Baiti"/>
+        <a:font script="Tibt" typeface="Microsoft Himalaya"/>
+        <a:font script="Thaa" typeface="MV Boli"/>
+        <a:font script="Deva" typeface="Mangal"/>
+        <a:font script="Telu" typeface="Gautami"/>
+        <a:font script="Taml" typeface="Latha"/>
+        <a:font script="Syrc" typeface="Estrangelo Edessa"/>
+        <a:font script="Orya" typeface="Kalinga"/>
+        <a:font script="Mlym" typeface="Kartika"/>
+        <a:font script="Laoo" typeface="DokChampa"/>
+        <a:font script="Sinh" typeface="Iskoola Pota"/>
+        <a:font script="Mong" typeface="Mongolian Baiti"/>
+        <a:font script="Viet" typeface="Arial"/>
+        <a:font script="Uigh" typeface="Microsoft Uighur"/>
+        <a:font script="Geor" typeface="Sylfaen"/>
+      </a:minorFont>
+    </a:fontScheme>
+    <a:fmtScheme name="Office">
+      <a:fillStyleLst>
+        <a:solidFill>
+          <a:schemeClr val="phClr"/>
+        </a:solidFill>
+        <a:gradFill rotWithShape="1">
+          <a:gsLst>
+            <a:gs pos="0">
+              <a:schemeClr val="phClr">
+                <a:tint val="50000"/>
+                <a:satMod val="300000"/>
+              </a:schemeClr>
+            </a:gs>
+            <a:gs pos="35000">
+              <a:schemeClr val="phClr">
+                <a:tint val="37000"/>
+                <a:satMod val="300000"/>
+              </a:schemeClr>
+            </a:gs>
+            <a:gs pos="100000">
+              <a:schemeClr val="phClr">
+                <a:tint val="15000"/>
+                <a:satMod val="350000"/>
+              </a:schemeClr>
+            </a:gs>
+          </a:gsLst>
+          <a:lin ang="16200000" scaled="1"/>
+        </a:gradFill>
+        <a:gradFill rotWithShape="1">
+          <a:gsLst>
+            <a:gs pos="0">
+              <a:schemeClr val="phClr">
+                <a:tint val="100000"/>
+                <a:shade val="100000"/>
+                <a:satMod val="130000"/>
+              </a:schemeClr>
+            </a:gs>
+            <a:gs pos="100000">
+              <a:schemeClr val="phClr">
+                <a:tint val="50000"/>
+                <a:shade val="100000"/>
+                <a:satMod val="350000"/>
+              </a:schemeClr>
+            </a:gs>
+          </a:gsLst>
+          <a:lin ang="16200000" scaled="0"/>
+        </a:gradFill>
+      </a:fillStyleLst>
+      <a:lnStyleLst>
+        <a:ln w="9525" cap="flat" cmpd="sng" algn="ctr">
+          <a:solidFill>
+            <a:schemeClr val="phClr">
+              <a:shade val="95000"/>
+              <a:satMod val="105000"/>
+            </a:schemeClr>
+          </a:solidFill>
+          <a:prstDash val="solid"/>
+        </a:ln>
+        <a:ln w="25400" cap="flat" cmpd="sng" algn="ctr">
+          <a:solidFill>
+            <a:schemeClr val="phClr"/>
+          </a:solidFill>
+          <a:prstDash val="solid"/>
+        </a:ln>
+        <a:ln w="38100" cap="flat" cmpd="sng" algn="ctr">
+          <a:solidFill>
+            <a:schemeClr val="phClr"/>
+          </a:solidFill>
+          <a:prstDash val="solid"/>
+        </a:ln>
+      </a:lnStyleLst>
+      <a:effectStyleLst>
+        <a:effectStyle>
+          <a:effectLst>
+            <a:outerShdw blurRad="40000" dist="20000" dir="5400000" rotWithShape="0">
+              <a:srgbClr val="000000">
+                <a:alpha val="38000"/>
+              </a:srgbClr>
+            </a:outerShdw>
+          </a:effectLst>
+        </a:effectStyle>
+        <a:effectStyle>
+          <a:effectLst>
+            <a:outerShdw blurRad="40000" dist="23000" dir="5400000" rotWithShape="0">
+              <a:srgbClr val="000000">
+                <a:alpha val="35000"/>
+              </a:srgbClr>
+            </a:outerShdw>
+          </a:effectLst>
+        </a:effectStyle>
+        <a:effectStyle>
+          <a:effectLst>
+            <a:outerShdw blurRad="40000" dist="23000" dir="5400000" rotWithShape="0">
+              <a:srgbClr val="000000">
+                <a:alpha val="35000"/>
+              </a:srgbClr>
+            </a:outerShdw>
+          </a:effectLst>
+          <a:scene3d>
+            <a:camera prst="orthographicFront">
+              <a:rot lat="0" lon="0" rev="0"/>
+            </a:camera>
+            <a:lightRig rig="threePt" dir="t">
+              <a:rot lat="0" lon="0" rev="1200000"/>
+            </a:lightRig>
+          </a:scene3d>
+          <a:sp3d>
+            <a:bevelT w="63500" h="25400"/>
+          </a:sp3d>
+        </a:effectStyle>
+      </a:effectStyleLst>
+      <a:bgFillStyleLst>
+        <a:solidFill>
+          <a:schemeClr val="phClr"/>
+        </a:solidFill>
+        <a:gradFill rotWithShape="1">
+          <a:gsLst>
+            <a:gs pos="0">
+              <a:schemeClr val="phClr">
+                <a:tint val="40000"/>
+                <a:satMod val="350000"/>
+              </a:schemeClr>
+            </a:gs>
+            <a:gs pos="40000">
+              <a:schemeClr val="phClr">
+                <a:tint val="45000"/>
+                <a:shade val="99000"/>
+                <a:satMod val="350000"/>
+              </a:schemeClr>
+            </a:gs>
+            <a:gs pos="100000">
+              <a:schemeClr val="phClr">
+                <a:shade val="20000"/>
+                <a:satMod val="255000"/>
+              </a:schemeClr>
+            </a:gs>
+          </a:gsLst>
+          <a:path path="circle">
+            <a:fillToRect l="50000" t="-80000" r="50000" b="180000"/>
+          </a:path>
+        </a:gradFill>
+        <a:gradFill rotWithShape="1">
+          <a:gsLst>
+            <a:gs pos="0">
+              <a:schemeClr val="phClr">
+                <a:tint val="80000"/>
+                <a:satMod val="300000"/>
+              </a:schemeClr>
+            </a:gs>
+            <a:gs pos="100000">
+              <a:schemeClr val="phClr">
+                <a:shade val="30000"/>
+                <a:satMod val="200000"/>
+              </a:schemeClr>
+            </a:gs>
+          </a:gsLst>
+          <a:path path="circle">
+            <a:fillToRect l="50000" t="50000" r="50000" b="50000"/>
+          </a:path>
+        </a:gradFill>
+      </a:bgFillStyleLst>
+    </a:fmtScheme>
+  </a:themeElements>
+  <a:objectDefaults>
+    <a:spDef>
+      <a:spPr/>
+      <a:bodyPr/>
+      <a:lstStyle/>
+      <a:style>
+        <a:lnRef idx="1">
+          <a:schemeClr val="accent1"/>
+        </a:lnRef>
+        <a:fillRef idx="3">
+          <a:schemeClr val="accent1"/>
+        </a:fillRef>
+        <a:effectRef idx="2">
+          <a:schemeClr val="accent1"/>
+        </a:effectRef>
+        <a:fontRef idx="minor">
+          <a:schemeClr val="lt1"/>
+        </a:fontRef>
+      </a:style>
+    </a:spDef>
+    <a:lnDef>
+      <a:spPr/>
+      <a:bodyPr/>
+      <a:lstStyle/>
+      <a:style>
+        <a:lnRef idx="2">
+          <a:schemeClr val="accent1"/>
+        </a:lnRef>
+        <a:fillRef idx="0">
+          <a:schemeClr val="accent1"/>
+        </a:fillRef>
+        <a:effectRef idx="1">
+          <a:schemeClr val="accent1"/>
+        </a:effectRef>
+        <a:fontRef idx="minor">
+          <a:schemeClr val="tx1"/>
+        </a:fontRef>
+      </a:style>
+    </a:lnDef>
+  </a:objectDefaults>
+  <a:extraClrSchemeLst/>
+</a:theme>
 </file>
</xml_diff>

<commit_message>
Fix table alignment and card overflow in the report deck
두 가지 레이아웃 문제를 고쳤다.

표의 열이 어긋나 있었다. 등폭 글꼴로 공백을 채워 칸을 맞췄는데, Cascadia Mono
에는 한글이 없어 대체 글꼴로 그려지고 그 글꼴은 고정폭이 아니다. 열마다 별도
텍스트 상자를 두고 숫자 열을 오른쪽 정렬하는 add_matrix 로 바꿨다. 글꼴과
무관하게 정렬이 맞고, 스테레오 행만 강조해 읽기 쉽게 했다.

첫 열이 한 행씩 밀리는 문제도 있었다. 비어 있는 머리글 칸의 문단이 기본 18pt
높이를 잡아 줄 간격이 어긋난 것이다. 런뿐 아니라 문단에도 글꼴 크기를 지정하는
style_paragraph 로 해결했다.

본문이 카드 아래로 넘쳤다. 그림 카드를 3.00 에서 2.75 인치로 줄이고 아래 카드를
1.83 에서 2.07 인치로 늘려 여유를 만들었다.

Co-Authored-By: Claude Opus 5 (1M context) <noreply@anthropic.com>
</commit_message>
<xml_diff>
--- a/report/2차업무_정승원.pptx
+++ b/report/2차업무_정승원.pptx
@@ -3898,6 +3898,12 @@
               <a:lnSpc>
                 <a:spcPct val="135000"/>
               </a:lnSpc>
+              <a:defRPr sz="850">
+                <a:solidFill>
+                  <a:srgbClr val="8F8F8F"/>
+                </a:solidFill>
+                <a:latin typeface="Cascadia Mono"/>
+              </a:defRPr>
             </a:pPr>
             <a:r>
               <a:rPr sz="850" b="0">
@@ -3939,6 +3945,12 @@
               <a:lnSpc>
                 <a:spcPct val="100000"/>
               </a:lnSpc>
+              <a:defRPr sz="2700">
+                <a:solidFill>
+                  <a:srgbClr val="171717"/>
+                </a:solidFill>
+                <a:latin typeface="Pretendard SemiBold"/>
+              </a:defRPr>
             </a:pPr>
             <a:r>
               <a:rPr sz="2700" b="0">
@@ -3980,6 +3992,12 @@
               <a:lnSpc>
                 <a:spcPct val="135000"/>
               </a:lnSpc>
+              <a:defRPr sz="1050">
+                <a:solidFill>
+                  <a:srgbClr val="4D4D4D"/>
+                </a:solidFill>
+                <a:latin typeface="Pretendard"/>
+              </a:defRPr>
             </a:pPr>
             <a:r>
               <a:rPr sz="1050" b="0">
@@ -4021,6 +4039,12 @@
               <a:lnSpc>
                 <a:spcPct val="135000"/>
               </a:lnSpc>
+              <a:defRPr sz="850">
+                <a:solidFill>
+                  <a:srgbClr val="A1A1A1"/>
+                </a:solidFill>
+                <a:latin typeface="Cascadia Mono"/>
+              </a:defRPr>
             </a:pPr>
             <a:r>
               <a:rPr sz="850" b="0">
@@ -4045,11 +4069,11 @@
         <p:spPr>
           <a:xfrm>
             <a:off x="658368" y="1627632"/>
-            <a:ext cx="10872216" cy="2743200"/>
+            <a:ext cx="10872216" cy="2514600"/>
           </a:xfrm>
           <a:prstGeom prst="roundRect">
             <a:avLst>
-              <a:gd name="adj" fmla="val 4166"/>
+              <a:gd name="adj" fmla="val 4545"/>
             </a:avLst>
           </a:prstGeom>
           <a:solidFill>
@@ -4100,8 +4124,8 @@
         </p:blipFill>
         <p:spPr>
           <a:xfrm>
-            <a:off x="1346629" y="1764792"/>
-            <a:ext cx="9495692" cy="2468880"/>
+            <a:off x="1786245" y="1764792"/>
+            <a:ext cx="8616461" cy="2240280"/>
           </a:xfrm>
           <a:prstGeom prst="rect">
             <a:avLst/>
@@ -4116,12 +4140,12 @@
         </p:nvSpPr>
         <p:spPr>
           <a:xfrm>
-            <a:off x="658368" y="4590288"/>
-            <a:ext cx="5358384" cy="1673352"/>
+            <a:off x="658368" y="4370832"/>
+            <a:ext cx="5358384" cy="1892807"/>
           </a:xfrm>
           <a:prstGeom prst="roundRect">
             <a:avLst>
-              <a:gd name="adj" fmla="val 6830"/>
+              <a:gd name="adj" fmla="val 6038"/>
             </a:avLst>
           </a:prstGeom>
           <a:solidFill>
@@ -4164,7 +4188,7 @@
         </p:nvSpPr>
         <p:spPr>
           <a:xfrm>
-            <a:off x="896112" y="4764024"/>
+            <a:off x="896112" y="4544568"/>
             <a:ext cx="4882896" cy="219456"/>
           </a:xfrm>
           <a:prstGeom prst="rect">
@@ -4182,6 +4206,12 @@
               <a:lnSpc>
                 <a:spcPct val="135000"/>
               </a:lnSpc>
+              <a:defRPr sz="1050">
+                <a:solidFill>
+                  <a:srgbClr val="171717"/>
+                </a:solidFill>
+                <a:latin typeface="Pretendard SemiBold"/>
+              </a:defRPr>
             </a:pPr>
             <a:r>
               <a:rPr sz="1050" b="0">
@@ -4205,8 +4235,8 @@
         </p:nvSpPr>
         <p:spPr>
           <a:xfrm>
-            <a:off x="896112" y="5010912"/>
-            <a:ext cx="4882896" cy="1069848"/>
+            <a:off x="896112" y="4791456"/>
+            <a:ext cx="4882896" cy="1289303"/>
           </a:xfrm>
           <a:prstGeom prst="rect">
             <a:avLst/>
@@ -4223,6 +4253,12 @@
               <a:lnSpc>
                 <a:spcPct val="130000"/>
               </a:lnSpc>
+              <a:defRPr sz="1000">
+                <a:solidFill>
+                  <a:srgbClr val="4D4D4D"/>
+                </a:solidFill>
+                <a:latin typeface="Pretendard"/>
+              </a:defRPr>
             </a:pPr>
             <a:r>
               <a:rPr sz="1000" b="0">
@@ -4241,6 +4277,12 @@
               <a:lnSpc>
                 <a:spcPct val="130000"/>
               </a:lnSpc>
+              <a:defRPr sz="1000">
+                <a:solidFill>
+                  <a:srgbClr val="4D4D4D"/>
+                </a:solidFill>
+                <a:latin typeface="Pretendard"/>
+              </a:defRPr>
             </a:pPr>
             <a:r>
               <a:rPr sz="1000" b="0">
@@ -4259,6 +4301,12 @@
               <a:lnSpc>
                 <a:spcPct val="130000"/>
               </a:lnSpc>
+              <a:defRPr sz="400">
+                <a:solidFill>
+                  <a:srgbClr val="4D4D4D"/>
+                </a:solidFill>
+                <a:latin typeface="Pretendard"/>
+              </a:defRPr>
             </a:pPr>
             <a:r>
               <a:rPr sz="400" b="0">
@@ -4277,6 +4325,12 @@
               <a:lnSpc>
                 <a:spcPct val="130000"/>
               </a:lnSpc>
+              <a:defRPr sz="1000">
+                <a:solidFill>
+                  <a:srgbClr val="171717"/>
+                </a:solidFill>
+                <a:latin typeface="Pretendard Medium"/>
+              </a:defRPr>
             </a:pPr>
             <a:r>
               <a:rPr sz="1000" b="0">
@@ -4295,6 +4349,12 @@
               <a:lnSpc>
                 <a:spcPct val="130000"/>
               </a:lnSpc>
+              <a:defRPr sz="1000">
+                <a:solidFill>
+                  <a:srgbClr val="171717"/>
+                </a:solidFill>
+                <a:latin typeface="Pretendard Medium"/>
+              </a:defRPr>
             </a:pPr>
             <a:r>
               <a:rPr sz="1000" b="0">
@@ -4313,6 +4373,12 @@
               <a:lnSpc>
                 <a:spcPct val="130000"/>
               </a:lnSpc>
+              <a:defRPr sz="1000">
+                <a:solidFill>
+                  <a:srgbClr val="4D4D4D"/>
+                </a:solidFill>
+                <a:latin typeface="Pretendard"/>
+              </a:defRPr>
             </a:pPr>
             <a:r>
               <a:rPr sz="1000" b="0">
@@ -4336,12 +4402,12 @@
         </p:nvSpPr>
         <p:spPr>
           <a:xfrm>
-            <a:off x="6364224" y="4590288"/>
-            <a:ext cx="5166360" cy="1673352"/>
+            <a:off x="6364224" y="4370832"/>
+            <a:ext cx="5166360" cy="1892807"/>
           </a:xfrm>
           <a:prstGeom prst="roundRect">
             <a:avLst>
-              <a:gd name="adj" fmla="val 6830"/>
+              <a:gd name="adj" fmla="val 6038"/>
             </a:avLst>
           </a:prstGeom>
           <a:solidFill>
@@ -4384,7 +4450,7 @@
         </p:nvSpPr>
         <p:spPr>
           <a:xfrm>
-            <a:off x="6601968" y="4764024"/>
+            <a:off x="6601968" y="4544568"/>
             <a:ext cx="4690872" cy="219456"/>
           </a:xfrm>
           <a:prstGeom prst="rect">
@@ -4402,6 +4468,12 @@
               <a:lnSpc>
                 <a:spcPct val="135000"/>
               </a:lnSpc>
+              <a:defRPr sz="1050">
+                <a:solidFill>
+                  <a:srgbClr val="171717"/>
+                </a:solidFill>
+                <a:latin typeface="Pretendard SemiBold"/>
+              </a:defRPr>
             </a:pPr>
             <a:r>
               <a:rPr sz="1050" b="0">
@@ -4425,8 +4497,8 @@
         </p:nvSpPr>
         <p:spPr>
           <a:xfrm>
-            <a:off x="6601968" y="5010912"/>
-            <a:ext cx="4690872" cy="1069848"/>
+            <a:off x="6601968" y="4791456"/>
+            <a:ext cx="4690872" cy="1289303"/>
           </a:xfrm>
           <a:prstGeom prst="rect">
             <a:avLst/>
@@ -4443,6 +4515,12 @@
               <a:lnSpc>
                 <a:spcPct val="130000"/>
               </a:lnSpc>
+              <a:defRPr sz="1000">
+                <a:solidFill>
+                  <a:srgbClr val="4D4D4D"/>
+                </a:solidFill>
+                <a:latin typeface="Pretendard"/>
+              </a:defRPr>
             </a:pPr>
             <a:r>
               <a:rPr sz="1000" b="0">
@@ -4461,6 +4539,12 @@
               <a:lnSpc>
                 <a:spcPct val="130000"/>
               </a:lnSpc>
+              <a:defRPr sz="1000">
+                <a:solidFill>
+                  <a:srgbClr val="4D4D4D"/>
+                </a:solidFill>
+                <a:latin typeface="Pretendard"/>
+              </a:defRPr>
             </a:pPr>
             <a:r>
               <a:rPr sz="1000" b="0">
@@ -4479,6 +4563,12 @@
               <a:lnSpc>
                 <a:spcPct val="130000"/>
               </a:lnSpc>
+              <a:defRPr sz="1000">
+                <a:solidFill>
+                  <a:srgbClr val="4D4D4D"/>
+                </a:solidFill>
+                <a:latin typeface="Pretendard"/>
+              </a:defRPr>
             </a:pPr>
             <a:r>
               <a:rPr sz="1000" b="0">
@@ -4497,6 +4587,12 @@
               <a:lnSpc>
                 <a:spcPct val="130000"/>
               </a:lnSpc>
+              <a:defRPr sz="1000">
+                <a:solidFill>
+                  <a:srgbClr val="171717"/>
+                </a:solidFill>
+                <a:latin typeface="Pretendard Medium"/>
+              </a:defRPr>
             </a:pPr>
             <a:r>
               <a:rPr sz="1000" b="0">
@@ -4515,6 +4611,12 @@
               <a:lnSpc>
                 <a:spcPct val="130000"/>
               </a:lnSpc>
+              <a:defRPr sz="1000">
+                <a:solidFill>
+                  <a:srgbClr val="171717"/>
+                </a:solidFill>
+                <a:latin typeface="Pretendard Medium"/>
+              </a:defRPr>
             </a:pPr>
             <a:r>
               <a:rPr sz="1000" b="0">
@@ -4618,6 +4720,12 @@
               <a:lnSpc>
                 <a:spcPct val="135000"/>
               </a:lnSpc>
+              <a:defRPr sz="850">
+                <a:solidFill>
+                  <a:srgbClr val="8F8F8F"/>
+                </a:solidFill>
+                <a:latin typeface="Cascadia Mono"/>
+              </a:defRPr>
             </a:pPr>
             <a:r>
               <a:rPr sz="850" b="0">
@@ -4659,6 +4767,12 @@
               <a:lnSpc>
                 <a:spcPct val="100000"/>
               </a:lnSpc>
+              <a:defRPr sz="2700">
+                <a:solidFill>
+                  <a:srgbClr val="171717"/>
+                </a:solidFill>
+                <a:latin typeface="Pretendard SemiBold"/>
+              </a:defRPr>
             </a:pPr>
             <a:r>
               <a:rPr sz="2700" b="0">
@@ -4700,6 +4814,12 @@
               <a:lnSpc>
                 <a:spcPct val="135000"/>
               </a:lnSpc>
+              <a:defRPr sz="1050">
+                <a:solidFill>
+                  <a:srgbClr val="4D4D4D"/>
+                </a:solidFill>
+                <a:latin typeface="Pretendard"/>
+              </a:defRPr>
             </a:pPr>
             <a:r>
               <a:rPr sz="1050" b="0">
@@ -4741,6 +4861,12 @@
               <a:lnSpc>
                 <a:spcPct val="135000"/>
               </a:lnSpc>
+              <a:defRPr sz="850">
+                <a:solidFill>
+                  <a:srgbClr val="A1A1A1"/>
+                </a:solidFill>
+                <a:latin typeface="Cascadia Mono"/>
+              </a:defRPr>
             </a:pPr>
             <a:r>
               <a:rPr sz="850" b="0">
@@ -4765,11 +4891,11 @@
         <p:spPr>
           <a:xfrm>
             <a:off x="658368" y="1627632"/>
-            <a:ext cx="10872216" cy="2743200"/>
+            <a:ext cx="10872216" cy="2514600"/>
           </a:xfrm>
           <a:prstGeom prst="roundRect">
             <a:avLst>
-              <a:gd name="adj" fmla="val 4166"/>
+              <a:gd name="adj" fmla="val 4545"/>
             </a:avLst>
           </a:prstGeom>
           <a:solidFill>
@@ -4820,8 +4946,8 @@
         </p:blipFill>
         <p:spPr>
           <a:xfrm>
-            <a:off x="795528" y="1821688"/>
-            <a:ext cx="10597896" cy="2355088"/>
+            <a:off x="1053846" y="1764792"/>
+            <a:ext cx="10081260" cy="2240280"/>
           </a:xfrm>
           <a:prstGeom prst="rect">
             <a:avLst/>
@@ -4836,12 +4962,12 @@
         </p:nvSpPr>
         <p:spPr>
           <a:xfrm>
-            <a:off x="658368" y="4590288"/>
-            <a:ext cx="5358384" cy="1673352"/>
+            <a:off x="658368" y="4370832"/>
+            <a:ext cx="5358384" cy="1892807"/>
           </a:xfrm>
           <a:prstGeom prst="roundRect">
             <a:avLst>
-              <a:gd name="adj" fmla="val 6830"/>
+              <a:gd name="adj" fmla="val 6038"/>
             </a:avLst>
           </a:prstGeom>
           <a:solidFill>
@@ -4884,7 +5010,7 @@
         </p:nvSpPr>
         <p:spPr>
           <a:xfrm>
-            <a:off x="896112" y="4764024"/>
+            <a:off x="896112" y="4544568"/>
             <a:ext cx="4882896" cy="219456"/>
           </a:xfrm>
           <a:prstGeom prst="rect">
@@ -4902,6 +5028,12 @@
               <a:lnSpc>
                 <a:spcPct val="135000"/>
               </a:lnSpc>
+              <a:defRPr sz="1050">
+                <a:solidFill>
+                  <a:srgbClr val="171717"/>
+                </a:solidFill>
+                <a:latin typeface="Pretendard SemiBold"/>
+              </a:defRPr>
             </a:pPr>
             <a:r>
               <a:rPr sz="1050" b="0">
@@ -4925,8 +5057,8 @@
         </p:nvSpPr>
         <p:spPr>
           <a:xfrm>
-            <a:off x="896112" y="5010912"/>
-            <a:ext cx="4882896" cy="1069848"/>
+            <a:off x="896112" y="4791456"/>
+            <a:ext cx="4882896" cy="1289303"/>
           </a:xfrm>
           <a:prstGeom prst="rect">
             <a:avLst/>
@@ -4943,6 +5075,12 @@
               <a:lnSpc>
                 <a:spcPct val="130000"/>
               </a:lnSpc>
+              <a:defRPr sz="1000">
+                <a:solidFill>
+                  <a:srgbClr val="4D4D4D"/>
+                </a:solidFill>
+                <a:latin typeface="Pretendard"/>
+              </a:defRPr>
             </a:pPr>
             <a:r>
               <a:rPr sz="1000" b="0">
@@ -4961,6 +5099,12 @@
               <a:lnSpc>
                 <a:spcPct val="130000"/>
               </a:lnSpc>
+              <a:defRPr sz="1000">
+                <a:solidFill>
+                  <a:srgbClr val="4D4D4D"/>
+                </a:solidFill>
+                <a:latin typeface="Pretendard"/>
+              </a:defRPr>
             </a:pPr>
             <a:r>
               <a:rPr sz="1000" b="0">
@@ -4974,16 +5118,45 @@
               <a:t>과제 예시 코드에는 정답에 맞춘 최적 정렬까지 해 줬습니다.</a:t>
             </a:r>
           </a:p>
+        </p:txBody>
+      </p:sp>
+      <p:sp>
+        <p:nvSpPr>
+          <p:cNvPr id="12" name="TextBox 11"/>
+          <p:cNvSpPr txBox="1"/>
+          <p:nvPr/>
+        </p:nvSpPr>
+        <p:spPr>
+          <a:xfrm>
+            <a:off x="896112" y="5212080"/>
+            <a:ext cx="1417320" cy="859536"/>
+          </a:xfrm>
+          <a:prstGeom prst="rect">
+            <a:avLst/>
+          </a:prstGeom>
+          <a:noFill/>
+        </p:spPr>
+        <p:txBody>
+          <a:bodyPr wrap="none" lIns="0" rIns="0" tIns="0" bIns="0">
+            <a:spAutoFit/>
+          </a:bodyPr>
+          <a:lstStyle/>
           <a:p>
             <a:pPr algn="l">
               <a:lnSpc>
-                <a:spcPct val="130000"/>
+                <a:spcPct val="145000"/>
               </a:lnSpc>
+              <a:defRPr sz="900">
+                <a:solidFill>
+                  <a:srgbClr val="8F8F8F"/>
+                </a:solidFill>
+                <a:latin typeface="Pretendard"/>
+              </a:defRPr>
             </a:pPr>
             <a:r>
-              <a:rPr sz="400" b="0">
-                <a:solidFill>
-                  <a:srgbClr val="4D4D4D"/>
+              <a:rPr sz="900" b="0">
+                <a:solidFill>
+                  <a:srgbClr val="8F8F8F"/>
                 </a:solidFill>
                 <a:latin typeface="Pretendard"/>
                 <a:ea typeface="Pretendard"/>
@@ -4995,91 +5168,448 @@
           <a:p>
             <a:pPr algn="l">
               <a:lnSpc>
-                <a:spcPct val="130000"/>
+                <a:spcPct val="145000"/>
               </a:lnSpc>
+              <a:defRPr sz="1000">
+                <a:solidFill>
+                  <a:srgbClr val="4D4D4D"/>
+                </a:solidFill>
+                <a:latin typeface="Pretendard"/>
+              </a:defRPr>
             </a:pPr>
             <a:r>
-              <a:rPr sz="950" b="0">
+              <a:rPr sz="1000" b="0">
                 <a:solidFill>
                   <a:srgbClr val="4D4D4D"/>
                 </a:solidFill>
-                <a:latin typeface="Cascadia Mono"/>
-                <a:ea typeface="Cascadia Mono"/>
-                <a:cs typeface="Cascadia Mono"/>
+                <a:latin typeface="Pretendard"/>
+                <a:ea typeface="Pretendard"/>
+                <a:cs typeface="Pretendard"/>
               </a:rPr>
-              <a:t>                깊이 폭    오차 중앙값   5cm 이내</a:t>
+              <a:t>정답</a:t>
             </a:r>
           </a:p>
           <a:p>
             <a:pPr algn="l">
               <a:lnSpc>
-                <a:spcPct val="130000"/>
+                <a:spcPct val="145000"/>
               </a:lnSpc>
+              <a:defRPr sz="1000">
+                <a:solidFill>
+                  <a:srgbClr val="171717"/>
+                </a:solidFill>
+                <a:latin typeface="Pretendard Medium"/>
+              </a:defRPr>
             </a:pPr>
             <a:r>
-              <a:rPr sz="950" b="0">
-                <a:solidFill>
-                  <a:srgbClr val="4D4D4D"/>
-                </a:solidFill>
-                <a:latin typeface="Cascadia Mono"/>
-                <a:ea typeface="Cascadia Mono"/>
-                <a:cs typeface="Cascadia Mono"/>
+              <a:rPr sz="1000" b="0">
+                <a:solidFill>
+                  <a:srgbClr val="171717"/>
+                </a:solidFill>
+                <a:latin typeface="Pretendard Medium"/>
+                <a:ea typeface="Pretendard Medium"/>
+                <a:cs typeface="Pretendard Medium"/>
               </a:rPr>
-              <a:t>정  답          0.898 m         —          —</a:t>
+              <a:t>스테레오</a:t>
             </a:r>
           </a:p>
           <a:p>
             <a:pPr algn="l">
               <a:lnSpc>
-                <a:spcPct val="130000"/>
+                <a:spcPct val="145000"/>
               </a:lnSpc>
+              <a:defRPr sz="1000">
+                <a:solidFill>
+                  <a:srgbClr val="4D4D4D"/>
+                </a:solidFill>
+                <a:latin typeface="Pretendard"/>
+              </a:defRPr>
             </a:pPr>
             <a:r>
-              <a:rPr sz="950" b="0">
+              <a:rPr sz="1000" b="0">
                 <a:solidFill>
                   <a:srgbClr val="4D4D4D"/>
                 </a:solidFill>
-                <a:latin typeface="Cascadia Mono"/>
-                <a:ea typeface="Cascadia Mono"/>
-                <a:cs typeface="Cascadia Mono"/>
+                <a:latin typeface="Pretendard"/>
+                <a:ea typeface="Pretendard"/>
+                <a:cs typeface="Pretendard"/>
               </a:rPr>
-              <a:t>스테레오        0.915 m        1.0 cm      96.1%</a:t>
-            </a:r>
-          </a:p>
-          <a:p>
-            <a:pPr algn="l">
+              <a:t>과제 예시</a:t>
+            </a:r>
+          </a:p>
+        </p:txBody>
+      </p:sp>
+      <p:sp>
+        <p:nvSpPr>
+          <p:cNvPr id="13" name="TextBox 12"/>
+          <p:cNvSpPr txBox="1"/>
+          <p:nvPr/>
+        </p:nvSpPr>
+        <p:spPr>
+          <a:xfrm>
+            <a:off x="2313432" y="5212080"/>
+            <a:ext cx="1143000" cy="859536"/>
+          </a:xfrm>
+          <a:prstGeom prst="rect">
+            <a:avLst/>
+          </a:prstGeom>
+          <a:noFill/>
+        </p:spPr>
+        <p:txBody>
+          <a:bodyPr wrap="none" lIns="0" rIns="0" tIns="0" bIns="0">
+            <a:spAutoFit/>
+          </a:bodyPr>
+          <a:lstStyle/>
+          <a:p>
+            <a:pPr algn="r">
               <a:lnSpc>
-                <a:spcPct val="130000"/>
+                <a:spcPct val="145000"/>
               </a:lnSpc>
+              <a:defRPr sz="900">
+                <a:solidFill>
+                  <a:srgbClr val="8F8F8F"/>
+                </a:solidFill>
+                <a:latin typeface="Pretendard"/>
+              </a:defRPr>
             </a:pPr>
             <a:r>
-              <a:rPr sz="950" b="0">
+              <a:rPr sz="900" b="0">
+                <a:solidFill>
+                  <a:srgbClr val="8F8F8F"/>
+                </a:solidFill>
+                <a:latin typeface="Pretendard"/>
+                <a:ea typeface="Pretendard"/>
+                <a:cs typeface="Pretendard"/>
+              </a:rPr>
+              <a:t>깊이 폭</a:t>
+            </a:r>
+          </a:p>
+          <a:p>
+            <a:pPr algn="r">
+              <a:lnSpc>
+                <a:spcPct val="145000"/>
+              </a:lnSpc>
+              <a:defRPr sz="1000">
                 <a:solidFill>
                   <a:srgbClr val="4D4D4D"/>
                 </a:solidFill>
-                <a:latin typeface="Cascadia Mono"/>
-                <a:ea typeface="Cascadia Mono"/>
-                <a:cs typeface="Cascadia Mono"/>
+                <a:latin typeface="Pretendard"/>
+              </a:defRPr>
+            </a:pPr>
+            <a:r>
+              <a:rPr sz="1000" b="0">
+                <a:solidFill>
+                  <a:srgbClr val="4D4D4D"/>
+                </a:solidFill>
+                <a:latin typeface="Pretendard"/>
+                <a:ea typeface="Pretendard"/>
+                <a:cs typeface="Pretendard"/>
               </a:rPr>
-              <a:t>과제 예시       0.017 m        7.2 cm      33.5%</a:t>
-            </a:r>
-          </a:p>
-        </p:txBody>
-      </p:sp>
-      <p:sp>
-        <p:nvSpPr>
-          <p:cNvPr id="12" name="Rounded Rectangle 11"/>
+              <a:t>0.898 m</a:t>
+            </a:r>
+          </a:p>
+          <a:p>
+            <a:pPr algn="r">
+              <a:lnSpc>
+                <a:spcPct val="145000"/>
+              </a:lnSpc>
+              <a:defRPr sz="1000">
+                <a:solidFill>
+                  <a:srgbClr val="171717"/>
+                </a:solidFill>
+                <a:latin typeface="Pretendard Medium"/>
+              </a:defRPr>
+            </a:pPr>
+            <a:r>
+              <a:rPr sz="1000" b="0">
+                <a:solidFill>
+                  <a:srgbClr val="171717"/>
+                </a:solidFill>
+                <a:latin typeface="Pretendard Medium"/>
+                <a:ea typeface="Pretendard Medium"/>
+                <a:cs typeface="Pretendard Medium"/>
+              </a:rPr>
+              <a:t>0.915 m</a:t>
+            </a:r>
+          </a:p>
+          <a:p>
+            <a:pPr algn="r">
+              <a:lnSpc>
+                <a:spcPct val="145000"/>
+              </a:lnSpc>
+              <a:defRPr sz="1000">
+                <a:solidFill>
+                  <a:srgbClr val="4D4D4D"/>
+                </a:solidFill>
+                <a:latin typeface="Pretendard"/>
+              </a:defRPr>
+            </a:pPr>
+            <a:r>
+              <a:rPr sz="1000" b="0">
+                <a:solidFill>
+                  <a:srgbClr val="4D4D4D"/>
+                </a:solidFill>
+                <a:latin typeface="Pretendard"/>
+                <a:ea typeface="Pretendard"/>
+                <a:cs typeface="Pretendard"/>
+              </a:rPr>
+              <a:t>0.017 m</a:t>
+            </a:r>
+          </a:p>
+        </p:txBody>
+      </p:sp>
+      <p:sp>
+        <p:nvSpPr>
+          <p:cNvPr id="14" name="TextBox 13"/>
+          <p:cNvSpPr txBox="1"/>
+          <p:nvPr/>
+        </p:nvSpPr>
+        <p:spPr>
+          <a:xfrm>
+            <a:off x="3456432" y="5212080"/>
+            <a:ext cx="1188720" cy="859536"/>
+          </a:xfrm>
+          <a:prstGeom prst="rect">
+            <a:avLst/>
+          </a:prstGeom>
+          <a:noFill/>
+        </p:spPr>
+        <p:txBody>
+          <a:bodyPr wrap="none" lIns="0" rIns="0" tIns="0" bIns="0">
+            <a:spAutoFit/>
+          </a:bodyPr>
+          <a:lstStyle/>
+          <a:p>
+            <a:pPr algn="r">
+              <a:lnSpc>
+                <a:spcPct val="145000"/>
+              </a:lnSpc>
+              <a:defRPr sz="900">
+                <a:solidFill>
+                  <a:srgbClr val="8F8F8F"/>
+                </a:solidFill>
+                <a:latin typeface="Pretendard"/>
+              </a:defRPr>
+            </a:pPr>
+            <a:r>
+              <a:rPr sz="900" b="0">
+                <a:solidFill>
+                  <a:srgbClr val="8F8F8F"/>
+                </a:solidFill>
+                <a:latin typeface="Pretendard"/>
+                <a:ea typeface="Pretendard"/>
+                <a:cs typeface="Pretendard"/>
+              </a:rPr>
+              <a:t>오차 중앙값</a:t>
+            </a:r>
+          </a:p>
+          <a:p>
+            <a:pPr algn="r">
+              <a:lnSpc>
+                <a:spcPct val="145000"/>
+              </a:lnSpc>
+              <a:defRPr sz="1000">
+                <a:solidFill>
+                  <a:srgbClr val="4D4D4D"/>
+                </a:solidFill>
+                <a:latin typeface="Pretendard"/>
+              </a:defRPr>
+            </a:pPr>
+            <a:r>
+              <a:rPr sz="1000" b="0">
+                <a:solidFill>
+                  <a:srgbClr val="4D4D4D"/>
+                </a:solidFill>
+                <a:latin typeface="Pretendard"/>
+                <a:ea typeface="Pretendard"/>
+                <a:cs typeface="Pretendard"/>
+              </a:rPr>
+              <a:t>—</a:t>
+            </a:r>
+          </a:p>
+          <a:p>
+            <a:pPr algn="r">
+              <a:lnSpc>
+                <a:spcPct val="145000"/>
+              </a:lnSpc>
+              <a:defRPr sz="1000">
+                <a:solidFill>
+                  <a:srgbClr val="171717"/>
+                </a:solidFill>
+                <a:latin typeface="Pretendard Medium"/>
+              </a:defRPr>
+            </a:pPr>
+            <a:r>
+              <a:rPr sz="1000" b="0">
+                <a:solidFill>
+                  <a:srgbClr val="171717"/>
+                </a:solidFill>
+                <a:latin typeface="Pretendard Medium"/>
+                <a:ea typeface="Pretendard Medium"/>
+                <a:cs typeface="Pretendard Medium"/>
+              </a:rPr>
+              <a:t>1.0 cm</a:t>
+            </a:r>
+          </a:p>
+          <a:p>
+            <a:pPr algn="r">
+              <a:lnSpc>
+                <a:spcPct val="145000"/>
+              </a:lnSpc>
+              <a:defRPr sz="1000">
+                <a:solidFill>
+                  <a:srgbClr val="4D4D4D"/>
+                </a:solidFill>
+                <a:latin typeface="Pretendard"/>
+              </a:defRPr>
+            </a:pPr>
+            <a:r>
+              <a:rPr sz="1000" b="0">
+                <a:solidFill>
+                  <a:srgbClr val="4D4D4D"/>
+                </a:solidFill>
+                <a:latin typeface="Pretendard"/>
+                <a:ea typeface="Pretendard"/>
+                <a:cs typeface="Pretendard"/>
+              </a:rPr>
+              <a:t>7.2 cm</a:t>
+            </a:r>
+          </a:p>
+        </p:txBody>
+      </p:sp>
+      <p:sp>
+        <p:nvSpPr>
+          <p:cNvPr id="15" name="TextBox 14"/>
+          <p:cNvSpPr txBox="1"/>
+          <p:nvPr/>
+        </p:nvSpPr>
+        <p:spPr>
+          <a:xfrm>
+            <a:off x="4645152" y="5212080"/>
+            <a:ext cx="960120" cy="859536"/>
+          </a:xfrm>
+          <a:prstGeom prst="rect">
+            <a:avLst/>
+          </a:prstGeom>
+          <a:noFill/>
+        </p:spPr>
+        <p:txBody>
+          <a:bodyPr wrap="none" lIns="0" rIns="0" tIns="0" bIns="0">
+            <a:spAutoFit/>
+          </a:bodyPr>
+          <a:lstStyle/>
+          <a:p>
+            <a:pPr algn="r">
+              <a:lnSpc>
+                <a:spcPct val="145000"/>
+              </a:lnSpc>
+              <a:defRPr sz="900">
+                <a:solidFill>
+                  <a:srgbClr val="8F8F8F"/>
+                </a:solidFill>
+                <a:latin typeface="Pretendard"/>
+              </a:defRPr>
+            </a:pPr>
+            <a:r>
+              <a:rPr sz="900" b="0">
+                <a:solidFill>
+                  <a:srgbClr val="8F8F8F"/>
+                </a:solidFill>
+                <a:latin typeface="Pretendard"/>
+                <a:ea typeface="Pretendard"/>
+                <a:cs typeface="Pretendard"/>
+              </a:rPr>
+              <a:t>5cm 이내</a:t>
+            </a:r>
+          </a:p>
+          <a:p>
+            <a:pPr algn="r">
+              <a:lnSpc>
+                <a:spcPct val="145000"/>
+              </a:lnSpc>
+              <a:defRPr sz="1000">
+                <a:solidFill>
+                  <a:srgbClr val="4D4D4D"/>
+                </a:solidFill>
+                <a:latin typeface="Pretendard"/>
+              </a:defRPr>
+            </a:pPr>
+            <a:r>
+              <a:rPr sz="1000" b="0">
+                <a:solidFill>
+                  <a:srgbClr val="4D4D4D"/>
+                </a:solidFill>
+                <a:latin typeface="Pretendard"/>
+                <a:ea typeface="Pretendard"/>
+                <a:cs typeface="Pretendard"/>
+              </a:rPr>
+              <a:t>—</a:t>
+            </a:r>
+          </a:p>
+          <a:p>
+            <a:pPr algn="r">
+              <a:lnSpc>
+                <a:spcPct val="145000"/>
+              </a:lnSpc>
+              <a:defRPr sz="1000">
+                <a:solidFill>
+                  <a:srgbClr val="171717"/>
+                </a:solidFill>
+                <a:latin typeface="Pretendard Medium"/>
+              </a:defRPr>
+            </a:pPr>
+            <a:r>
+              <a:rPr sz="1000" b="0">
+                <a:solidFill>
+                  <a:srgbClr val="171717"/>
+                </a:solidFill>
+                <a:latin typeface="Pretendard Medium"/>
+                <a:ea typeface="Pretendard Medium"/>
+                <a:cs typeface="Pretendard Medium"/>
+              </a:rPr>
+              <a:t>96.1%</a:t>
+            </a:r>
+          </a:p>
+          <a:p>
+            <a:pPr algn="r">
+              <a:lnSpc>
+                <a:spcPct val="145000"/>
+              </a:lnSpc>
+              <a:defRPr sz="1000">
+                <a:solidFill>
+                  <a:srgbClr val="4D4D4D"/>
+                </a:solidFill>
+                <a:latin typeface="Pretendard"/>
+              </a:defRPr>
+            </a:pPr>
+            <a:r>
+              <a:rPr sz="1000" b="0">
+                <a:solidFill>
+                  <a:srgbClr val="4D4D4D"/>
+                </a:solidFill>
+                <a:latin typeface="Pretendard"/>
+                <a:ea typeface="Pretendard"/>
+                <a:cs typeface="Pretendard"/>
+              </a:rPr>
+              <a:t>33.5%</a:t>
+            </a:r>
+          </a:p>
+        </p:txBody>
+      </p:sp>
+      <p:sp>
+        <p:nvSpPr>
+          <p:cNvPr id="16" name="Rounded Rectangle 15"/>
           <p:cNvSpPr/>
           <p:nvPr/>
         </p:nvSpPr>
         <p:spPr>
           <a:xfrm>
-            <a:off x="6364224" y="4590288"/>
-            <a:ext cx="5166360" cy="1673352"/>
+            <a:off x="6364224" y="4370832"/>
+            <a:ext cx="5166360" cy="1892807"/>
           </a:xfrm>
           <a:prstGeom prst="roundRect">
             <a:avLst>
-              <a:gd name="adj" fmla="val 6830"/>
+              <a:gd name="adj" fmla="val 6038"/>
             </a:avLst>
           </a:prstGeom>
           <a:solidFill>
@@ -5116,13 +5646,13 @@
       </p:sp>
       <p:sp>
         <p:nvSpPr>
-          <p:cNvPr id="13" name="TextBox 12"/>
+          <p:cNvPr id="17" name="TextBox 16"/>
           <p:cNvSpPr txBox="1"/>
           <p:nvPr/>
         </p:nvSpPr>
         <p:spPr>
           <a:xfrm>
-            <a:off x="6601968" y="4764024"/>
+            <a:off x="6601968" y="4544568"/>
             <a:ext cx="4690872" cy="219456"/>
           </a:xfrm>
           <a:prstGeom prst="rect">
@@ -5140,6 +5670,12 @@
               <a:lnSpc>
                 <a:spcPct val="135000"/>
               </a:lnSpc>
+              <a:defRPr sz="1050">
+                <a:solidFill>
+                  <a:srgbClr val="171717"/>
+                </a:solidFill>
+                <a:latin typeface="Pretendard SemiBold"/>
+              </a:defRPr>
             </a:pPr>
             <a:r>
               <a:rPr sz="1050" b="0">
@@ -5157,14 +5693,14 @@
       </p:sp>
       <p:sp>
         <p:nvSpPr>
-          <p:cNvPr id="14" name="TextBox 13"/>
+          <p:cNvPr id="18" name="TextBox 17"/>
           <p:cNvSpPr txBox="1"/>
           <p:nvPr/>
         </p:nvSpPr>
         <p:spPr>
           <a:xfrm>
-            <a:off x="6601968" y="5010912"/>
-            <a:ext cx="4690872" cy="1069848"/>
+            <a:off x="6601968" y="4791456"/>
+            <a:ext cx="4690872" cy="1289303"/>
           </a:xfrm>
           <a:prstGeom prst="rect">
             <a:avLst/>
@@ -5181,6 +5717,12 @@
               <a:lnSpc>
                 <a:spcPct val="130000"/>
               </a:lnSpc>
+              <a:defRPr sz="1000">
+                <a:solidFill>
+                  <a:srgbClr val="4D4D4D"/>
+                </a:solidFill>
+                <a:latin typeface="Pretendard"/>
+              </a:defRPr>
             </a:pPr>
             <a:r>
               <a:rPr sz="1000" b="0">
@@ -5199,6 +5741,12 @@
               <a:lnSpc>
                 <a:spcPct val="130000"/>
               </a:lnSpc>
+              <a:defRPr sz="1000">
+                <a:solidFill>
+                  <a:srgbClr val="4D4D4D"/>
+                </a:solidFill>
+                <a:latin typeface="Pretendard"/>
+              </a:defRPr>
             </a:pPr>
             <a:r>
               <a:rPr sz="1000" b="0">
@@ -5217,6 +5765,12 @@
               <a:lnSpc>
                 <a:spcPct val="130000"/>
               </a:lnSpc>
+              <a:defRPr sz="400">
+                <a:solidFill>
+                  <a:srgbClr val="4D4D4D"/>
+                </a:solidFill>
+                <a:latin typeface="Pretendard"/>
+              </a:defRPr>
             </a:pPr>
             <a:r>
               <a:rPr sz="400" b="0">
@@ -5235,6 +5789,12 @@
               <a:lnSpc>
                 <a:spcPct val="130000"/>
               </a:lnSpc>
+              <a:defRPr sz="1000">
+                <a:solidFill>
+                  <a:srgbClr val="171717"/>
+                </a:solidFill>
+                <a:latin typeface="Pretendard Medium"/>
+              </a:defRPr>
             </a:pPr>
             <a:r>
               <a:rPr sz="1000" b="0">
@@ -5253,6 +5813,12 @@
               <a:lnSpc>
                 <a:spcPct val="130000"/>
               </a:lnSpc>
+              <a:defRPr sz="1000">
+                <a:solidFill>
+                  <a:srgbClr val="171717"/>
+                </a:solidFill>
+                <a:latin typeface="Pretendard Medium"/>
+              </a:defRPr>
             </a:pPr>
             <a:r>
               <a:rPr sz="1000" b="0">
@@ -5271,6 +5837,12 @@
               <a:lnSpc>
                 <a:spcPct val="130000"/>
               </a:lnSpc>
+              <a:defRPr sz="1000">
+                <a:solidFill>
+                  <a:srgbClr val="171717"/>
+                </a:solidFill>
+                <a:latin typeface="Pretendard Medium"/>
+              </a:defRPr>
             </a:pPr>
             <a:r>
               <a:rPr sz="1000" b="0">
@@ -5289,6 +5861,12 @@
               <a:lnSpc>
                 <a:spcPct val="130000"/>
               </a:lnSpc>
+              <a:defRPr sz="1000">
+                <a:solidFill>
+                  <a:srgbClr val="4D4D4D"/>
+                </a:solidFill>
+                <a:latin typeface="Pretendard"/>
+              </a:defRPr>
             </a:pPr>
             <a:r>
               <a:rPr sz="1000" b="0">
@@ -5392,6 +5970,12 @@
               <a:lnSpc>
                 <a:spcPct val="135000"/>
               </a:lnSpc>
+              <a:defRPr sz="850">
+                <a:solidFill>
+                  <a:srgbClr val="8F8F8F"/>
+                </a:solidFill>
+                <a:latin typeface="Cascadia Mono"/>
+              </a:defRPr>
             </a:pPr>
             <a:r>
               <a:rPr sz="850" b="0">
@@ -5433,6 +6017,12 @@
               <a:lnSpc>
                 <a:spcPct val="100000"/>
               </a:lnSpc>
+              <a:defRPr sz="2700">
+                <a:solidFill>
+                  <a:srgbClr val="171717"/>
+                </a:solidFill>
+                <a:latin typeface="Pretendard SemiBold"/>
+              </a:defRPr>
             </a:pPr>
             <a:r>
               <a:rPr sz="2700" b="0">
@@ -5474,6 +6064,12 @@
               <a:lnSpc>
                 <a:spcPct val="135000"/>
               </a:lnSpc>
+              <a:defRPr sz="1050">
+                <a:solidFill>
+                  <a:srgbClr val="4D4D4D"/>
+                </a:solidFill>
+                <a:latin typeface="Pretendard"/>
+              </a:defRPr>
             </a:pPr>
             <a:r>
               <a:rPr sz="1050" b="0">
@@ -5515,6 +6111,12 @@
               <a:lnSpc>
                 <a:spcPct val="135000"/>
               </a:lnSpc>
+              <a:defRPr sz="850">
+                <a:solidFill>
+                  <a:srgbClr val="A1A1A1"/>
+                </a:solidFill>
+                <a:latin typeface="Cascadia Mono"/>
+              </a:defRPr>
             </a:pPr>
             <a:r>
               <a:rPr sz="850" b="0">
@@ -5676,6 +6278,12 @@
               <a:lnSpc>
                 <a:spcPct val="135000"/>
               </a:lnSpc>
+              <a:defRPr sz="1050">
+                <a:solidFill>
+                  <a:srgbClr val="171717"/>
+                </a:solidFill>
+                <a:latin typeface="Pretendard SemiBold"/>
+              </a:defRPr>
             </a:pPr>
             <a:r>
               <a:rPr sz="1050" b="0">
@@ -5699,8 +6307,8 @@
         </p:nvSpPr>
         <p:spPr>
           <a:xfrm>
-            <a:off x="896112" y="4590288"/>
-            <a:ext cx="5577840" cy="1490472"/>
+            <a:off x="896112" y="4617720"/>
+            <a:ext cx="1417320" cy="644652"/>
           </a:xfrm>
           <a:prstGeom prst="rect">
             <a:avLst/>
@@ -5708,6 +6316,386 @@
           <a:noFill/>
         </p:spPr>
         <p:txBody>
+          <a:bodyPr wrap="none" lIns="0" rIns="0" tIns="0" bIns="0">
+            <a:spAutoFit/>
+          </a:bodyPr>
+          <a:lstStyle/>
+          <a:p>
+            <a:pPr algn="l">
+              <a:lnSpc>
+                <a:spcPct val="145000"/>
+              </a:lnSpc>
+              <a:defRPr sz="900">
+                <a:solidFill>
+                  <a:srgbClr val="8F8F8F"/>
+                </a:solidFill>
+                <a:latin typeface="Pretendard"/>
+              </a:defRPr>
+            </a:pPr>
+            <a:r>
+              <a:rPr sz="900" b="0">
+                <a:solidFill>
+                  <a:srgbClr val="8F8F8F"/>
+                </a:solidFill>
+                <a:latin typeface="Pretendard"/>
+                <a:ea typeface="Pretendard"/>
+                <a:cs typeface="Pretendard"/>
+              </a:rPr>
+              <a:t/>
+            </a:r>
+          </a:p>
+          <a:p>
+            <a:pPr algn="l">
+              <a:lnSpc>
+                <a:spcPct val="145000"/>
+              </a:lnSpc>
+              <a:defRPr sz="1000">
+                <a:solidFill>
+                  <a:srgbClr val="171717"/>
+                </a:solidFill>
+                <a:latin typeface="Pretendard Medium"/>
+              </a:defRPr>
+            </a:pPr>
+            <a:r>
+              <a:rPr sz="1000" b="0">
+                <a:solidFill>
+                  <a:srgbClr val="171717"/>
+                </a:solidFill>
+                <a:latin typeface="Pretendard Medium"/>
+                <a:ea typeface="Pretendard Medium"/>
+                <a:cs typeface="Pretendard Medium"/>
+              </a:rPr>
+              <a:t>스테레오</a:t>
+            </a:r>
+          </a:p>
+          <a:p>
+            <a:pPr algn="l">
+              <a:lnSpc>
+                <a:spcPct val="145000"/>
+              </a:lnSpc>
+              <a:defRPr sz="1000">
+                <a:solidFill>
+                  <a:srgbClr val="4D4D4D"/>
+                </a:solidFill>
+                <a:latin typeface="Pretendard"/>
+              </a:defRPr>
+            </a:pPr>
+            <a:r>
+              <a:rPr sz="1000" b="0">
+                <a:solidFill>
+                  <a:srgbClr val="4D4D4D"/>
+                </a:solidFill>
+                <a:latin typeface="Pretendard"/>
+                <a:ea typeface="Pretendard"/>
+                <a:cs typeface="Pretendard"/>
+              </a:rPr>
+              <a:t>과제 예시</a:t>
+            </a:r>
+          </a:p>
+        </p:txBody>
+      </p:sp>
+      <p:sp>
+        <p:nvSpPr>
+          <p:cNvPr id="12" name="TextBox 11"/>
+          <p:cNvSpPr txBox="1"/>
+          <p:nvPr/>
+        </p:nvSpPr>
+        <p:spPr>
+          <a:xfrm>
+            <a:off x="2313432" y="4617720"/>
+            <a:ext cx="1280160" cy="644652"/>
+          </a:xfrm>
+          <a:prstGeom prst="rect">
+            <a:avLst/>
+          </a:prstGeom>
+          <a:noFill/>
+        </p:spPr>
+        <p:txBody>
+          <a:bodyPr wrap="none" lIns="0" rIns="0" tIns="0" bIns="0">
+            <a:spAutoFit/>
+          </a:bodyPr>
+          <a:lstStyle/>
+          <a:p>
+            <a:pPr algn="r">
+              <a:lnSpc>
+                <a:spcPct val="145000"/>
+              </a:lnSpc>
+              <a:defRPr sz="900">
+                <a:solidFill>
+                  <a:srgbClr val="8F8F8F"/>
+                </a:solidFill>
+                <a:latin typeface="Pretendard"/>
+              </a:defRPr>
+            </a:pPr>
+            <a:r>
+              <a:rPr sz="900" b="0">
+                <a:solidFill>
+                  <a:srgbClr val="8F8F8F"/>
+                </a:solidFill>
+                <a:latin typeface="Pretendard"/>
+                <a:ea typeface="Pretendard"/>
+                <a:cs typeface="Pretendard"/>
+              </a:rPr>
+              <a:t>RMSE</a:t>
+            </a:r>
+          </a:p>
+          <a:p>
+            <a:pPr algn="r">
+              <a:lnSpc>
+                <a:spcPct val="145000"/>
+              </a:lnSpc>
+              <a:defRPr sz="1000">
+                <a:solidFill>
+                  <a:srgbClr val="171717"/>
+                </a:solidFill>
+                <a:latin typeface="Pretendard Medium"/>
+              </a:defRPr>
+            </a:pPr>
+            <a:r>
+              <a:rPr sz="1000" b="0">
+                <a:solidFill>
+                  <a:srgbClr val="171717"/>
+                </a:solidFill>
+                <a:latin typeface="Pretendard Medium"/>
+                <a:ea typeface="Pretendard Medium"/>
+                <a:cs typeface="Pretendard Medium"/>
+              </a:rPr>
+              <a:t>0.0677 m</a:t>
+            </a:r>
+          </a:p>
+          <a:p>
+            <a:pPr algn="r">
+              <a:lnSpc>
+                <a:spcPct val="145000"/>
+              </a:lnSpc>
+              <a:defRPr sz="1000">
+                <a:solidFill>
+                  <a:srgbClr val="4D4D4D"/>
+                </a:solidFill>
+                <a:latin typeface="Pretendard"/>
+              </a:defRPr>
+            </a:pPr>
+            <a:r>
+              <a:rPr sz="1000" b="0">
+                <a:solidFill>
+                  <a:srgbClr val="4D4D4D"/>
+                </a:solidFill>
+                <a:latin typeface="Pretendard"/>
+                <a:ea typeface="Pretendard"/>
+                <a:cs typeface="Pretendard"/>
+              </a:rPr>
+              <a:t>0.0893 m</a:t>
+            </a:r>
+          </a:p>
+        </p:txBody>
+      </p:sp>
+      <p:sp>
+        <p:nvSpPr>
+          <p:cNvPr id="13" name="TextBox 12"/>
+          <p:cNvSpPr txBox="1"/>
+          <p:nvPr/>
+        </p:nvSpPr>
+        <p:spPr>
+          <a:xfrm>
+            <a:off x="3593592" y="4617720"/>
+            <a:ext cx="1280160" cy="644652"/>
+          </a:xfrm>
+          <a:prstGeom prst="rect">
+            <a:avLst/>
+          </a:prstGeom>
+          <a:noFill/>
+        </p:spPr>
+        <p:txBody>
+          <a:bodyPr wrap="none" lIns="0" rIns="0" tIns="0" bIns="0">
+            <a:spAutoFit/>
+          </a:bodyPr>
+          <a:lstStyle/>
+          <a:p>
+            <a:pPr algn="r">
+              <a:lnSpc>
+                <a:spcPct val="145000"/>
+              </a:lnSpc>
+              <a:defRPr sz="900">
+                <a:solidFill>
+                  <a:srgbClr val="8F8F8F"/>
+                </a:solidFill>
+                <a:latin typeface="Pretendard"/>
+              </a:defRPr>
+            </a:pPr>
+            <a:r>
+              <a:rPr sz="900" b="0">
+                <a:solidFill>
+                  <a:srgbClr val="8F8F8F"/>
+                </a:solidFill>
+                <a:latin typeface="Pretendard"/>
+                <a:ea typeface="Pretendard"/>
+                <a:cs typeface="Pretendard"/>
+              </a:rPr>
+              <a:t>오차 중앙값</a:t>
+            </a:r>
+          </a:p>
+          <a:p>
+            <a:pPr algn="r">
+              <a:lnSpc>
+                <a:spcPct val="145000"/>
+              </a:lnSpc>
+              <a:defRPr sz="1000">
+                <a:solidFill>
+                  <a:srgbClr val="171717"/>
+                </a:solidFill>
+                <a:latin typeface="Pretendard Medium"/>
+              </a:defRPr>
+            </a:pPr>
+            <a:r>
+              <a:rPr sz="1000" b="0">
+                <a:solidFill>
+                  <a:srgbClr val="171717"/>
+                </a:solidFill>
+                <a:latin typeface="Pretendard Medium"/>
+                <a:ea typeface="Pretendard Medium"/>
+                <a:cs typeface="Pretendard Medium"/>
+              </a:rPr>
+              <a:t>0.9 cm</a:t>
+            </a:r>
+          </a:p>
+          <a:p>
+            <a:pPr algn="r">
+              <a:lnSpc>
+                <a:spcPct val="145000"/>
+              </a:lnSpc>
+              <a:defRPr sz="1000">
+                <a:solidFill>
+                  <a:srgbClr val="4D4D4D"/>
+                </a:solidFill>
+                <a:latin typeface="Pretendard"/>
+              </a:defRPr>
+            </a:pPr>
+            <a:r>
+              <a:rPr sz="1000" b="0">
+                <a:solidFill>
+                  <a:srgbClr val="4D4D4D"/>
+                </a:solidFill>
+                <a:latin typeface="Pretendard"/>
+                <a:ea typeface="Pretendard"/>
+                <a:cs typeface="Pretendard"/>
+              </a:rPr>
+              <a:t>4.9 cm</a:t>
+            </a:r>
+          </a:p>
+        </p:txBody>
+      </p:sp>
+      <p:sp>
+        <p:nvSpPr>
+          <p:cNvPr id="14" name="TextBox 13"/>
+          <p:cNvSpPr txBox="1"/>
+          <p:nvPr/>
+        </p:nvSpPr>
+        <p:spPr>
+          <a:xfrm>
+            <a:off x="4873752" y="4617720"/>
+            <a:ext cx="1051560" cy="644652"/>
+          </a:xfrm>
+          <a:prstGeom prst="rect">
+            <a:avLst/>
+          </a:prstGeom>
+          <a:noFill/>
+        </p:spPr>
+        <p:txBody>
+          <a:bodyPr wrap="none" lIns="0" rIns="0" tIns="0" bIns="0">
+            <a:spAutoFit/>
+          </a:bodyPr>
+          <a:lstStyle/>
+          <a:p>
+            <a:pPr algn="r">
+              <a:lnSpc>
+                <a:spcPct val="145000"/>
+              </a:lnSpc>
+              <a:defRPr sz="900">
+                <a:solidFill>
+                  <a:srgbClr val="8F8F8F"/>
+                </a:solidFill>
+                <a:latin typeface="Pretendard"/>
+              </a:defRPr>
+            </a:pPr>
+            <a:r>
+              <a:rPr sz="900" b="0">
+                <a:solidFill>
+                  <a:srgbClr val="8F8F8F"/>
+                </a:solidFill>
+                <a:latin typeface="Pretendard"/>
+                <a:ea typeface="Pretendard"/>
+                <a:cs typeface="Pretendard"/>
+              </a:rPr>
+              <a:t>5cm 이내</a:t>
+            </a:r>
+          </a:p>
+          <a:p>
+            <a:pPr algn="r">
+              <a:lnSpc>
+                <a:spcPct val="145000"/>
+              </a:lnSpc>
+              <a:defRPr sz="1000">
+                <a:solidFill>
+                  <a:srgbClr val="171717"/>
+                </a:solidFill>
+                <a:latin typeface="Pretendard Medium"/>
+              </a:defRPr>
+            </a:pPr>
+            <a:r>
+              <a:rPr sz="1000" b="0">
+                <a:solidFill>
+                  <a:srgbClr val="171717"/>
+                </a:solidFill>
+                <a:latin typeface="Pretendard Medium"/>
+                <a:ea typeface="Pretendard Medium"/>
+                <a:cs typeface="Pretendard Medium"/>
+              </a:rPr>
+              <a:t>90.3%</a:t>
+            </a:r>
+          </a:p>
+          <a:p>
+            <a:pPr algn="r">
+              <a:lnSpc>
+                <a:spcPct val="145000"/>
+              </a:lnSpc>
+              <a:defRPr sz="1000">
+                <a:solidFill>
+                  <a:srgbClr val="4D4D4D"/>
+                </a:solidFill>
+                <a:latin typeface="Pretendard"/>
+              </a:defRPr>
+            </a:pPr>
+            <a:r>
+              <a:rPr sz="1000" b="0">
+                <a:solidFill>
+                  <a:srgbClr val="4D4D4D"/>
+                </a:solidFill>
+                <a:latin typeface="Pretendard"/>
+                <a:ea typeface="Pretendard"/>
+                <a:cs typeface="Pretendard"/>
+              </a:rPr>
+              <a:t>50.8%</a:t>
+            </a:r>
+          </a:p>
+        </p:txBody>
+      </p:sp>
+      <p:sp>
+        <p:nvSpPr>
+          <p:cNvPr id="15" name="TextBox 14"/>
+          <p:cNvSpPr txBox="1"/>
+          <p:nvPr/>
+        </p:nvSpPr>
+        <p:spPr>
+          <a:xfrm>
+            <a:off x="896112" y="5349240"/>
+            <a:ext cx="5577840" cy="841248"/>
+          </a:xfrm>
+          <a:prstGeom prst="rect">
+            <a:avLst/>
+          </a:prstGeom>
+          <a:noFill/>
+        </p:spPr>
+        <p:txBody>
           <a:bodyPr wrap="square" lIns="0" rIns="0" tIns="0" bIns="0">
             <a:spAutoFit/>
           </a:bodyPr>
@@ -5717,78 +6705,12 @@
               <a:lnSpc>
                 <a:spcPct val="130000"/>
               </a:lnSpc>
-            </a:pPr>
-            <a:r>
-              <a:rPr sz="950" b="0">
-                <a:solidFill>
-                  <a:srgbClr val="4D4D4D"/>
-                </a:solidFill>
-                <a:latin typeface="Cascadia Mono"/>
-                <a:ea typeface="Cascadia Mono"/>
-                <a:cs typeface="Cascadia Mono"/>
-              </a:rPr>
-              <a:t>                RMSE      오차 중앙값   5cm 이내</a:t>
-            </a:r>
-          </a:p>
-          <a:p>
-            <a:pPr algn="l">
-              <a:lnSpc>
-                <a:spcPct val="130000"/>
-              </a:lnSpc>
-            </a:pPr>
-            <a:r>
-              <a:rPr sz="950" b="0">
-                <a:solidFill>
-                  <a:srgbClr val="4D4D4D"/>
-                </a:solidFill>
-                <a:latin typeface="Cascadia Mono"/>
-                <a:ea typeface="Cascadia Mono"/>
-                <a:cs typeface="Cascadia Mono"/>
-              </a:rPr>
-              <a:t>스테레오        0.0677 m     0.9 cm      90.3%</a:t>
-            </a:r>
-          </a:p>
-          <a:p>
-            <a:pPr algn="l">
-              <a:lnSpc>
-                <a:spcPct val="130000"/>
-              </a:lnSpc>
-            </a:pPr>
-            <a:r>
-              <a:rPr sz="950" b="0">
-                <a:solidFill>
-                  <a:srgbClr val="4D4D4D"/>
-                </a:solidFill>
-                <a:latin typeface="Cascadia Mono"/>
-                <a:ea typeface="Cascadia Mono"/>
-                <a:cs typeface="Cascadia Mono"/>
-              </a:rPr>
-              <a:t>과제 예시       0.0893 m     4.9 cm      50.8%</a:t>
-            </a:r>
-          </a:p>
-          <a:p>
-            <a:pPr algn="l">
-              <a:lnSpc>
-                <a:spcPct val="130000"/>
-              </a:lnSpc>
-            </a:pPr>
-            <a:r>
-              <a:rPr sz="400" b="0">
-                <a:solidFill>
-                  <a:srgbClr val="4D4D4D"/>
-                </a:solidFill>
-                <a:latin typeface="Pretendard"/>
-                <a:ea typeface="Pretendard"/>
-                <a:cs typeface="Pretendard"/>
-              </a:rPr>
-              <a:t/>
-            </a:r>
-          </a:p>
-          <a:p>
-            <a:pPr algn="l">
-              <a:lnSpc>
-                <a:spcPct val="130000"/>
-              </a:lnSpc>
+              <a:defRPr sz="1000">
+                <a:solidFill>
+                  <a:srgbClr val="171717"/>
+                </a:solidFill>
+                <a:latin typeface="Pretendard Medium"/>
+              </a:defRPr>
             </a:pPr>
             <a:r>
               <a:rPr sz="1000" b="0">
@@ -5807,6 +6729,12 @@
               <a:lnSpc>
                 <a:spcPct val="130000"/>
               </a:lnSpc>
+              <a:defRPr sz="400">
+                <a:solidFill>
+                  <a:srgbClr val="4D4D4D"/>
+                </a:solidFill>
+                <a:latin typeface="Pretendard"/>
+              </a:defRPr>
             </a:pPr>
             <a:r>
               <a:rPr sz="400" b="0">
@@ -5825,6 +6753,12 @@
               <a:lnSpc>
                 <a:spcPct val="130000"/>
               </a:lnSpc>
+              <a:defRPr sz="1000">
+                <a:solidFill>
+                  <a:srgbClr val="4D4D4D"/>
+                </a:solidFill>
+                <a:latin typeface="Pretendard"/>
+              </a:defRPr>
             </a:pPr>
             <a:r>
               <a:rPr sz="1000" b="0">
@@ -5835,7 +6769,7 @@
                 <a:ea typeface="Pretendard"/>
                 <a:cs typeface="Pretendard"/>
               </a:rPr>
-              <a:t>한계 — 조건을 만족하는 쌍이 후보 20개 중 3개, 유효화소 59%,</a:t>
+              <a:t>한계 — 쓸 만한 쌍이 후보 20개 중 3개, 유효화소 59%, 단일 시점이라 뒷면은 복원 불가,</a:t>
             </a:r>
           </a:p>
           <a:p>
@@ -5843,6 +6777,12 @@
               <a:lnSpc>
                 <a:spcPct val="130000"/>
               </a:lnSpc>
+              <a:defRPr sz="1000">
+                <a:solidFill>
+                  <a:srgbClr val="4D4D4D"/>
+                </a:solidFill>
+                <a:latin typeface="Pretendard"/>
+              </a:defRPr>
             </a:pPr>
             <a:r>
               <a:rPr sz="1000" b="0">
@@ -5853,32 +6793,14 @@
                 <a:ea typeface="Pretendard"/>
                 <a:cs typeface="Pretendard"/>
               </a:rPr>
-              <a:t>단일 시점이라 뒷면은 복원 불가, 정답 자세를 그대로 사용,</a:t>
-            </a:r>
-          </a:p>
-          <a:p>
-            <a:pPr algn="l">
-              <a:lnSpc>
-                <a:spcPct val="130000"/>
-              </a:lnSpc>
-            </a:pPr>
-            <a:r>
-              <a:rPr sz="1000" b="0">
-                <a:solidFill>
-                  <a:srgbClr val="4D4D4D"/>
-                </a:solidFill>
-                <a:latin typeface="Pretendard"/>
-                <a:ea typeface="Pretendard"/>
-                <a:cs typeface="Pretendard"/>
-              </a:rPr>
-              <a:t>깊이 분해능 하한 6.8 cm/px (dZ = Z²/fB)</a:t>
-            </a:r>
-          </a:p>
-        </p:txBody>
-      </p:sp>
-      <p:sp>
-        <p:nvSpPr>
-          <p:cNvPr id="12" name="Rounded Rectangle 11"/>
+              <a:t>정답 자세를 그대로 사용, 깊이 분해능 하한 6.8 cm/px (dZ = Z²/fB)</a:t>
+            </a:r>
+          </a:p>
+        </p:txBody>
+      </p:sp>
+      <p:sp>
+        <p:nvSpPr>
+          <p:cNvPr id="16" name="Rounded Rectangle 15"/>
           <p:cNvSpPr/>
           <p:nvPr/>
         </p:nvSpPr>
@@ -5926,7 +6848,7 @@
       </p:sp>
       <p:pic>
         <p:nvPicPr>
-          <p:cNvPr id="13" name="Picture 12" descr="04_pointclouds.png"/>
+          <p:cNvPr id="17" name="Picture 16" descr="04_pointclouds.png"/>
           <p:cNvPicPr>
             <a:picLocks noChangeAspect="1"/>
           </p:cNvPicPr>

</xml_diff>